<commit_message>
Translate investor deck to French and remove Normandie Pet Food
- Translated all 12 slides from English to French
- Removed all Normandie Pet Food JV references (slides 2, 3, 11)
- Replaced Normandie highlight with multi-market proximity highlight
- Updated EU market card to focus on geographic proximity
- Reduced partners from 4 to 3 on slide 11 (FAMSUN, Petland, Soufiane)
- Fixed slide 10 title overlap caused by longer French text
</commit_message>
<xml_diff>
--- a/PetFactory_Infrastructure_Investor_Deck.pptx
+++ b/PetFactory_Infrastructure_Investor_Deck.pptx
@@ -1966,7 +1966,7 @@
                 <a:ea typeface="Calibri" pitchFamily="34" charset="-122"/>
                 <a:cs typeface="Calibri" pitchFamily="34" charset="-120"/>
               </a:rPr>
-              <a:t>MOROCCO</a:t>
+              <a:t>MAROC</a:t>
             </a:r>
             <a:endParaRPr lang="en-US" sz="4400" dirty="0"/>
           </a:p>
@@ -2005,7 +2005,7 @@
                 <a:ea typeface="Arial" pitchFamily="34" charset="-122"/>
                 <a:cs typeface="Arial" pitchFamily="34" charset="-120"/>
               </a:rPr>
-              <a:t>Infrastructure Progress Report</a:t>
+              <a:t>Rapport d'avancement Infrastructure</a:t>
             </a:r>
             <a:endParaRPr lang="en-US" sz="2200" dirty="0"/>
           </a:p>
@@ -2044,7 +2044,7 @@
                 <a:ea typeface="Arial" pitchFamily="34" charset="-122"/>
                 <a:cs typeface="Arial" pitchFamily="34" charset="-120"/>
               </a:rPr>
-              <a:t>Investor Update  |  August 2026</a:t>
+              <a:t>Mise à jour Investisseurs  |  Août 2026</a:t>
             </a:r>
             <a:endParaRPr lang="en-US" sz="1400" dirty="0"/>
           </a:p>
@@ -2097,7 +2097,7 @@
                 <a:ea typeface="Arial" pitchFamily="34" charset="-122"/>
                 <a:cs typeface="Arial" pitchFamily="34" charset="-120"/>
               </a:rPr>
-              <a:t>Dry Extrusion Line   |   </a:t>
+              <a:t>Ligne d'extrusion sèche   |   </a:t>
             </a:r>
             <a:pPr indent="0" marL="0">
               <a:buNone/>
@@ -2125,7 +2125,7 @@
                 <a:ea typeface="Arial" pitchFamily="34" charset="-122"/>
                 <a:cs typeface="Arial" pitchFamily="34" charset="-120"/>
               </a:rPr>
-              <a:t>Turnkey   |   </a:t>
+              <a:t>Clé en main   |   </a:t>
             </a:r>
             <a:pPr indent="0" marL="0">
               <a:buNone/>
@@ -2139,7 +2139,7 @@
                 <a:ea typeface="Arial" pitchFamily="34" charset="-122"/>
                 <a:cs typeface="Arial" pitchFamily="34" charset="-120"/>
               </a:rPr>
-              <a:t>Sidi Bouathmane, Morocco</a:t>
+              <a:t>Sidi Bouathmane, Maroc</a:t>
             </a:r>
             <a:endParaRPr lang="en-US" sz="1300" dirty="0"/>
           </a:p>
@@ -2178,7 +2178,7 @@
                 <a:ea typeface="Arial" pitchFamily="34" charset="-122"/>
                 <a:cs typeface="Arial" pitchFamily="34" charset="-120"/>
               </a:rPr>
-              <a:t>Petland Maroc  |  100% Ownership  |  Confidential</a:t>
+              <a:t>Petland Maroc  |  Propriété 100%  |  Confidentiel</a:t>
             </a:r>
             <a:endParaRPr lang="en-US" sz="900" dirty="0"/>
           </a:p>
@@ -2224,8 +2224,8 @@
         </p:nvSpPr>
         <p:spPr>
           <a:xfrm>
-            <a:off x="640080" y="365760"/>
-            <a:ext cx="7315200" cy="548640"/>
+            <a:off x="640080" y="274320"/>
+            <a:ext cx="10972800" cy="548640"/>
           </a:xfrm>
           <a:prstGeom prst="rect">
             <a:avLst/>
@@ -2249,7 +2249,7 @@
                 <a:ea typeface="Calibri" pitchFamily="34" charset="-122"/>
                 <a:cs typeface="Calibri" pitchFamily="34" charset="-120"/>
               </a:rPr>
-              <a:t>Digital Twin &amp; Technology</a:t>
+              <a:t>Jumeau Numérique &amp; Technologie</a:t>
             </a:r>
             <a:endParaRPr lang="en-US" sz="3200" dirty="0"/>
           </a:p>
@@ -2263,8 +2263,8 @@
         </p:nvSpPr>
         <p:spPr>
           <a:xfrm>
-            <a:off x="640080" y="868680"/>
-            <a:ext cx="9144000" cy="320040"/>
+            <a:off x="640080" y="822960"/>
+            <a:ext cx="10972800" cy="320040"/>
           </a:xfrm>
           <a:prstGeom prst="rect">
             <a:avLst/>
@@ -2288,7 +2288,7 @@
                 <a:ea typeface="Arial" pitchFamily="34" charset="-122"/>
                 <a:cs typeface="Arial" pitchFamily="34" charset="-120"/>
               </a:rPr>
-              <a:t>Process simulation built before commissioning — de-risking production parameters</a:t>
+              <a:t>Simulation de procédé construite avant mise en service — réduction des risques de production</a:t>
             </a:r>
             <a:endParaRPr lang="en-US" sz="1300" dirty="0"/>
           </a:p>
@@ -2415,7 +2415,7 @@
                 <a:ea typeface="Calibri" pitchFamily="34" charset="-122"/>
                 <a:cs typeface="Calibri" pitchFamily="34" charset="-120"/>
               </a:rPr>
-              <a:t>Full Process Model</a:t>
+              <a:t>Modèle Complet</a:t>
             </a:r>
             <a:endParaRPr lang="en-US" sz="1300" dirty="0"/>
           </a:p>
@@ -2457,7 +2457,7 @@
                 <a:ea typeface="Arial" pitchFamily="34" charset="-122"/>
                 <a:cs typeface="Arial" pitchFamily="34" charset="-120"/>
               </a:rPr>
-              <a:t>7 unit operations modeled: raw materials through packaging, with real FAMSUN equipment parameters</a:t>
+              <a:t>7 opérations unitaires modélisées : matières premières jusqu'au conditionnement, avec paramètres réels FAMSUN</a:t>
             </a:r>
             <a:endParaRPr lang="en-US" sz="1000" dirty="0"/>
           </a:p>
@@ -2584,7 +2584,7 @@
                 <a:ea typeface="Calibri" pitchFamily="34" charset="-122"/>
                 <a:cs typeface="Calibri" pitchFamily="34" charset="-120"/>
               </a:rPr>
-              <a:t>Scenario Comparison</a:t>
+              <a:t>Comparaison de Scénarios</a:t>
             </a:r>
             <a:endParaRPr lang="en-US" sz="1300" dirty="0"/>
           </a:p>
@@ -2626,7 +2626,7 @@
                 <a:ea typeface="Arial" pitchFamily="34" charset="-122"/>
                 <a:cs typeface="Arial" pitchFamily="34" charset="-120"/>
               </a:rPr>
-              <a:t>Compare production scenarios side-by-side: throughput variations, recipe changes, seasonal adjustments</a:t>
+              <a:t>Comparaison côte à côte : variations de débit, changements de recettes, ajustements saisonniers</a:t>
             </a:r>
             <a:endParaRPr lang="en-US" sz="1000" dirty="0"/>
           </a:p>
@@ -2753,7 +2753,7 @@
                 <a:ea typeface="Calibri" pitchFamily="34" charset="-122"/>
                 <a:cs typeface="Calibri" pitchFamily="34" charset="-120"/>
               </a:rPr>
-              <a:t>Energy Optimization</a:t>
+              <a:t>Optimisation Énergétique</a:t>
             </a:r>
             <a:endParaRPr lang="en-US" sz="1300" dirty="0"/>
           </a:p>
@@ -2795,7 +2795,7 @@
                 <a:ea typeface="Arial" pitchFamily="34" charset="-122"/>
                 <a:cs typeface="Arial" pitchFamily="34" charset="-120"/>
               </a:rPr>
-              <a:t>Steam, electricity, and water cost modeling at real Moroccan utility rates (MAD/kWh, MAD/m³)</a:t>
+              <a:t>Modélisation coûts vapeur, électricité et eau aux tarifs réels marocains (MAD/kWh, MAD/m³)</a:t>
             </a:r>
             <a:endParaRPr lang="en-US" sz="1000" dirty="0"/>
           </a:p>
@@ -2922,7 +2922,7 @@
                 <a:ea typeface="Calibri" pitchFamily="34" charset="-122"/>
                 <a:cs typeface="Calibri" pitchFamily="34" charset="-120"/>
               </a:rPr>
-              <a:t>Live Dashboard</a:t>
+              <a:t>Tableau de Bord en Direct</a:t>
             </a:r>
             <a:endParaRPr lang="en-US" sz="1300" dirty="0"/>
           </a:p>
@@ -2964,7 +2964,7 @@
                 <a:ea typeface="Arial" pitchFamily="34" charset="-122"/>
                 <a:cs typeface="Arial" pitchFamily="34" charset="-120"/>
               </a:rPr>
-              <a:t>Real-time monitoring dashboard with live engine simulation for operator training pre-commissioning</a:t>
+              <a:t>Tableau de bord temps réel avec simulation moteur pour formation opérateurs avant mise en service</a:t>
             </a:r>
             <a:endParaRPr lang="en-US" sz="1000" dirty="0"/>
           </a:p>
@@ -3091,7 +3091,7 @@
                 <a:ea typeface="Calibri" pitchFamily="34" charset="-122"/>
                 <a:cs typeface="Calibri" pitchFamily="34" charset="-120"/>
               </a:rPr>
-              <a:t>Quality Prediction</a:t>
+              <a:t>Prédiction Qualité</a:t>
             </a:r>
             <a:endParaRPr lang="en-US" sz="1300" dirty="0"/>
           </a:p>
@@ -3133,7 +3133,7 @@
                 <a:ea typeface="Arial" pitchFamily="34" charset="-122"/>
                 <a:cs typeface="Arial" pitchFamily="34" charset="-120"/>
               </a:rPr>
-              <a:t>Moisture, water activity, density tracking at each stage with target validation and alerts</a:t>
+              <a:t>Suivi humidité, activité de l'eau, densité à chaque étape avec validation cibles et alertes</a:t>
             </a:r>
             <a:endParaRPr lang="en-US" sz="1000" dirty="0"/>
           </a:p>
@@ -3260,7 +3260,7 @@
                 <a:ea typeface="Calibri" pitchFamily="34" charset="-122"/>
                 <a:cs typeface="Calibri" pitchFamily="34" charset="-120"/>
               </a:rPr>
-              <a:t>Recipe Optimizer</a:t>
+              <a:t>Optimiseur de Recettes</a:t>
             </a:r>
             <a:endParaRPr lang="en-US" sz="1300" dirty="0"/>
           </a:p>
@@ -3302,7 +3302,7 @@
                 <a:ea typeface="Arial" pitchFamily="34" charset="-122"/>
                 <a:cs typeface="Arial" pitchFamily="34" charset="-120"/>
               </a:rPr>
-              <a:t>Automated optimization of process parameters for cost, quality, and throughput targets</a:t>
+              <a:t>Optimisation automatisée des paramètres procédé pour coût, qualité et objectifs de débit</a:t>
             </a:r>
             <a:endParaRPr lang="en-US" sz="1000" dirty="0"/>
           </a:p>
@@ -3363,7 +3363,7 @@
                 <a:ea typeface="Arial" pitchFamily="34" charset="-122"/>
                 <a:cs typeface="Arial" pitchFamily="34" charset="-120"/>
               </a:rPr>
-              <a:t>Utility Rates Modeled:   </a:t>
+              <a:t>Tarifs modélisés :   </a:t>
             </a:r>
             <a:pPr indent="0" marL="0">
               <a:buNone/>
@@ -3377,7 +3377,7 @@
                 <a:ea typeface="Arial" pitchFamily="34" charset="-122"/>
                 <a:cs typeface="Arial" pitchFamily="34" charset="-120"/>
               </a:rPr>
-              <a:t>Steam: 0.18 MAD/kg   |   Electricity: 1.20 MAD/kWh   |   Water: 8.50 MAD/m³</a:t>
+              <a:t>Vapeur : 0,18 MAD/kg   |   Électricité : 1,20 MAD/kWh   |   Eau : 8,50 MAD/m³</a:t>
             </a:r>
             <a:endParaRPr lang="en-US" sz="1000" dirty="0"/>
           </a:p>
@@ -3416,7 +3416,7 @@
                 <a:ea typeface="Arial" pitchFamily="34" charset="-122"/>
                 <a:cs typeface="Arial" pitchFamily="34" charset="-120"/>
               </a:rPr>
-              <a:t>PetFactory Maroc  |  Investor Update  |  August 2026</a:t>
+              <a:t>PetFactory Maroc  |  Mise à jour Investisseurs  |  Août 2026</a:t>
             </a:r>
             <a:endParaRPr lang="en-US" sz="800" dirty="0"/>
           </a:p>
@@ -3487,7 +3487,7 @@
                 <a:ea typeface="Calibri" pitchFamily="34" charset="-122"/>
                 <a:cs typeface="Calibri" pitchFamily="34" charset="-120"/>
               </a:rPr>
-              <a:t>Partners &amp; Team</a:t>
+              <a:t>Partenaires &amp; Équipe</a:t>
             </a:r>
             <a:endParaRPr lang="en-US" sz="3200" dirty="0"/>
           </a:p>
@@ -3502,11 +3502,11 @@
         <p:spPr>
           <a:xfrm>
             <a:off x="640080" y="1097280"/>
-            <a:ext cx="10927080" cy="1051560"/>
+            <a:ext cx="10927080" cy="1188720"/>
           </a:xfrm>
           <a:prstGeom prst="roundRect">
             <a:avLst>
-              <a:gd name="adj" fmla="val 8696"/>
+              <a:gd name="adj" fmla="val 7692"/>
             </a:avLst>
           </a:prstGeom>
           <a:solidFill>
@@ -3530,7 +3530,7 @@
         </p:nvSpPr>
         <p:spPr>
           <a:xfrm>
-            <a:off x="914400" y="1280160"/>
+            <a:off x="914400" y="1325880"/>
             <a:ext cx="640080" cy="640080"/>
           </a:xfrm>
           <a:prstGeom prst="ellipse">
@@ -3550,7 +3550,7 @@
         </p:nvSpPr>
         <p:spPr>
           <a:xfrm>
-            <a:off x="914400" y="1298448"/>
+            <a:off x="914400" y="1344168"/>
             <a:ext cx="640080" cy="594360"/>
           </a:xfrm>
           <a:prstGeom prst="rect">
@@ -3589,7 +3589,7 @@
         </p:nvSpPr>
         <p:spPr>
           <a:xfrm>
-            <a:off x="1783080" y="1207008"/>
+            <a:off x="1783080" y="1234440"/>
             <a:ext cx="2743200" cy="320040"/>
           </a:xfrm>
           <a:prstGeom prst="rect">
@@ -3628,7 +3628,7 @@
         </p:nvSpPr>
         <p:spPr>
           <a:xfrm>
-            <a:off x="1783080" y="1508760"/>
+            <a:off x="1783080" y="1554480"/>
             <a:ext cx="2743200" cy="228600"/>
           </a:xfrm>
           <a:prstGeom prst="rect">
@@ -3653,7 +3653,7 @@
                 <a:ea typeface="Arial" pitchFamily="34" charset="-122"/>
                 <a:cs typeface="Arial" pitchFamily="34" charset="-120"/>
               </a:rPr>
-              <a:t>Turnkey Production Line</a:t>
+              <a:t>Ligne de production clé en main</a:t>
             </a:r>
             <a:endParaRPr lang="en-US" sz="1100" dirty="0"/>
           </a:p>
@@ -3668,7 +3668,7 @@
         <p:spPr>
           <a:xfrm>
             <a:off x="4754880" y="1234440"/>
-            <a:ext cx="6583680" cy="777240"/>
+            <a:ext cx="6583680" cy="914400"/>
           </a:xfrm>
           <a:prstGeom prst="rect">
             <a:avLst/>
@@ -3695,7 +3695,7 @@
                 <a:ea typeface="Arial" pitchFamily="34" charset="-122"/>
                 <a:cs typeface="Arial" pitchFamily="34" charset="-120"/>
               </a:rPr>
-              <a:t>SJPS165 twin-screw extruder, dryer, preconditioner, coater, cooler, packaging, silos. Full installation supervision and performance guarantees.</a:t>
+              <a:t>Extrudeuse bi-vis SJPS165, séchoir, préconditionneur, enrobeur, refroidisseur, conditionnement, silos. Supervision complète de l'installation et garanties de performance.</a:t>
             </a:r>
             <a:endParaRPr lang="en-US" sz="1050" dirty="0"/>
           </a:p>
@@ -3709,12 +3709,12 @@
         </p:nvSpPr>
         <p:spPr>
           <a:xfrm>
-            <a:off x="640080" y="2194560"/>
-            <a:ext cx="10927080" cy="1051560"/>
+            <a:off x="640080" y="2377440"/>
+            <a:ext cx="10927080" cy="1188720"/>
           </a:xfrm>
           <a:prstGeom prst="roundRect">
             <a:avLst>
-              <a:gd name="adj" fmla="val 8696"/>
+              <a:gd name="adj" fmla="val 7692"/>
             </a:avLst>
           </a:prstGeom>
           <a:solidFill>
@@ -3738,14 +3738,14 @@
         </p:nvSpPr>
         <p:spPr>
           <a:xfrm>
-            <a:off x="914400" y="2377440"/>
+            <a:off x="914400" y="2606040"/>
             <a:ext cx="640080" cy="640080"/>
           </a:xfrm>
           <a:prstGeom prst="ellipse">
             <a:avLst/>
           </a:prstGeom>
           <a:solidFill>
-            <a:srgbClr val="E8963E"/>
+            <a:srgbClr val="1B2A4A"/>
           </a:solidFill>
           <a:ln/>
         </p:spPr>
@@ -3758,7 +3758,7 @@
         </p:nvSpPr>
         <p:spPr>
           <a:xfrm>
-            <a:off x="914400" y="2395728"/>
+            <a:off x="914400" y="2624328"/>
             <a:ext cx="640080" cy="594360"/>
           </a:xfrm>
           <a:prstGeom prst="rect">
@@ -3783,7 +3783,7 @@
                 <a:ea typeface="Calibri" pitchFamily="34" charset="-122"/>
                 <a:cs typeface="Calibri" pitchFamily="34" charset="-120"/>
               </a:rPr>
-              <a:t>N</a:t>
+              <a:t>P</a:t>
             </a:r>
             <a:endParaRPr lang="en-US" sz="2800" dirty="0"/>
           </a:p>
@@ -3797,7 +3797,7 @@
         </p:nvSpPr>
         <p:spPr>
           <a:xfrm>
-            <a:off x="1783080" y="2304288"/>
+            <a:off x="1783080" y="2514600"/>
             <a:ext cx="2743200" cy="320040"/>
           </a:xfrm>
           <a:prstGeom prst="rect">
@@ -3822,7 +3822,7 @@
                 <a:ea typeface="Calibri" pitchFamily="34" charset="-122"/>
                 <a:cs typeface="Calibri" pitchFamily="34" charset="-120"/>
               </a:rPr>
-              <a:t>Normandie Pet Food</a:t>
+              <a:t>Petland Maroc</a:t>
             </a:r>
             <a:endParaRPr lang="en-US" sz="1600" dirty="0"/>
           </a:p>
@@ -3836,7 +3836,7 @@
         </p:nvSpPr>
         <p:spPr>
           <a:xfrm>
-            <a:off x="1783080" y="2606040"/>
+            <a:off x="1783080" y="2834640"/>
             <a:ext cx="2743200" cy="228600"/>
           </a:xfrm>
           <a:prstGeom prst="rect">
@@ -3855,13 +3855,13 @@
             <a:r>
               <a:rPr lang="en-US" sz="1100" dirty="0">
                 <a:solidFill>
-                  <a:srgbClr val="E8963E"/>
-                </a:solidFill>
-                <a:latin typeface="Arial" pitchFamily="34" charset="0"/>
-                <a:ea typeface="Arial" pitchFamily="34" charset="-122"/>
-                <a:cs typeface="Arial" pitchFamily="34" charset="-120"/>
-              </a:rPr>
-              <a:t>EU Market JV Partner</a:t>
+                  <a:srgbClr val="1B2A4A"/>
+                </a:solidFill>
+                <a:latin typeface="Arial" pitchFamily="34" charset="0"/>
+                <a:ea typeface="Arial" pitchFamily="34" charset="-122"/>
+                <a:cs typeface="Arial" pitchFamily="34" charset="-120"/>
+              </a:rPr>
+              <a:t>Propriétaire 100% de l'usine</a:t>
             </a:r>
             <a:endParaRPr lang="en-US" sz="1100" dirty="0"/>
           </a:p>
@@ -3875,8 +3875,8 @@
         </p:nvSpPr>
         <p:spPr>
           <a:xfrm>
-            <a:off x="4754880" y="2331720"/>
-            <a:ext cx="6583680" cy="777240"/>
+            <a:off x="4754880" y="2514600"/>
+            <a:ext cx="6583680" cy="914400"/>
           </a:xfrm>
           <a:prstGeom prst="rect">
             <a:avLst/>
@@ -3903,7 +3903,7 @@
                 <a:ea typeface="Arial" pitchFamily="34" charset="-122"/>
                 <a:cs typeface="Arial" pitchFamily="34" charset="-120"/>
               </a:rPr>
-              <a:t>French partner targeting EUR 300M revenue by 2030. Capitalized through Bpifrance and Credit Agricole. No equity lock-up, no capacity exclusivity.</a:t>
+              <a:t>Sam Aribi, Chef de Projet. Propriété intégrale conservée. Indépendance opérationnelle et flexibilité stratégique totales.</a:t>
             </a:r>
             <a:endParaRPr lang="en-US" sz="1050" dirty="0"/>
           </a:p>
@@ -3917,12 +3917,12 @@
         </p:nvSpPr>
         <p:spPr>
           <a:xfrm>
-            <a:off x="640080" y="3291840"/>
-            <a:ext cx="10927080" cy="1051560"/>
+            <a:off x="640080" y="3657600"/>
+            <a:ext cx="10927080" cy="1188720"/>
           </a:xfrm>
           <a:prstGeom prst="roundRect">
             <a:avLst>
-              <a:gd name="adj" fmla="val 8696"/>
+              <a:gd name="adj" fmla="val 7692"/>
             </a:avLst>
           </a:prstGeom>
           <a:solidFill>
@@ -3946,14 +3946,14 @@
         </p:nvSpPr>
         <p:spPr>
           <a:xfrm>
-            <a:off x="914400" y="3474720"/>
+            <a:off x="914400" y="3886200"/>
             <a:ext cx="640080" cy="640080"/>
           </a:xfrm>
           <a:prstGeom prst="ellipse">
             <a:avLst/>
           </a:prstGeom>
           <a:solidFill>
-            <a:srgbClr val="1B2A4A"/>
+            <a:srgbClr val="27AE60"/>
           </a:solidFill>
           <a:ln/>
         </p:spPr>
@@ -3966,7 +3966,7 @@
         </p:nvSpPr>
         <p:spPr>
           <a:xfrm>
-            <a:off x="914400" y="3493008"/>
+            <a:off x="914400" y="3904488"/>
             <a:ext cx="640080" cy="594360"/>
           </a:xfrm>
           <a:prstGeom prst="rect">
@@ -3991,7 +3991,7 @@
                 <a:ea typeface="Calibri" pitchFamily="34" charset="-122"/>
                 <a:cs typeface="Calibri" pitchFamily="34" charset="-120"/>
               </a:rPr>
-              <a:t>P</a:t>
+              <a:t>S</a:t>
             </a:r>
             <a:endParaRPr lang="en-US" sz="2800" dirty="0"/>
           </a:p>
@@ -4005,7 +4005,7 @@
         </p:nvSpPr>
         <p:spPr>
           <a:xfrm>
-            <a:off x="1783080" y="3401568"/>
+            <a:off x="1783080" y="3794760"/>
             <a:ext cx="2743200" cy="320040"/>
           </a:xfrm>
           <a:prstGeom prst="rect">
@@ -4030,7 +4030,7 @@
                 <a:ea typeface="Calibri" pitchFamily="34" charset="-122"/>
                 <a:cs typeface="Calibri" pitchFamily="34" charset="-120"/>
               </a:rPr>
-              <a:t>Petland Maroc</a:t>
+              <a:t>Soufiane Incendie</a:t>
             </a:r>
             <a:endParaRPr lang="en-US" sz="1600" dirty="0"/>
           </a:p>
@@ -4044,7 +4044,7 @@
         </p:nvSpPr>
         <p:spPr>
           <a:xfrm>
-            <a:off x="1783080" y="3703320"/>
+            <a:off x="1783080" y="4114800"/>
             <a:ext cx="2743200" cy="228600"/>
           </a:xfrm>
           <a:prstGeom prst="rect">
@@ -4063,13 +4063,13 @@
             <a:r>
               <a:rPr lang="en-US" sz="1100" dirty="0">
                 <a:solidFill>
-                  <a:srgbClr val="1B2A4A"/>
-                </a:solidFill>
-                <a:latin typeface="Arial" pitchFamily="34" charset="0"/>
-                <a:ea typeface="Arial" pitchFamily="34" charset="-122"/>
-                <a:cs typeface="Arial" pitchFamily="34" charset="-120"/>
-              </a:rPr>
-              <a:t>100% Factory Owner</a:t>
+                  <a:srgbClr val="27AE60"/>
+                </a:solidFill>
+                <a:latin typeface="Arial" pitchFamily="34" charset="0"/>
+                <a:ea typeface="Arial" pitchFamily="34" charset="-122"/>
+                <a:cs typeface="Arial" pitchFamily="34" charset="-120"/>
+              </a:rPr>
+              <a:t>Prestataire Sécurité Incendie</a:t>
             </a:r>
             <a:endParaRPr lang="en-US" sz="1100" dirty="0"/>
           </a:p>
@@ -4083,8 +4083,8 @@
         </p:nvSpPr>
         <p:spPr>
           <a:xfrm>
-            <a:off x="4754880" y="3429000"/>
-            <a:ext cx="6583680" cy="777240"/>
+            <a:off x="4754880" y="3794760"/>
+            <a:ext cx="6583680" cy="914400"/>
           </a:xfrm>
           <a:prstGeom prst="rect">
             <a:avLst/>
@@ -4111,7 +4111,7 @@
                 <a:ea typeface="Arial" pitchFamily="34" charset="-122"/>
                 <a:cs typeface="Arial" pitchFamily="34" charset="-120"/>
               </a:rPr>
-              <a:t>Sam Aribi, Chef de Projet. Full ownership retained. Contractual JV structure preserves operational independence and strategic flexibility.</a:t>
+              <a:t>Dossier complet NSI ERT, plans PCI (RDC &amp; 1er étage), conception système de pressurisation, autorisations de modification du bâtiment.</a:t>
             </a:r>
             <a:endParaRPr lang="en-US" sz="1050" dirty="0"/>
           </a:p>
@@ -4125,309 +4125,101 @@
         </p:nvSpPr>
         <p:spPr>
           <a:xfrm>
-            <a:off x="640080" y="4389120"/>
-            <a:ext cx="10927080" cy="1051560"/>
+            <a:off x="640080" y="5212080"/>
+            <a:ext cx="10927080" cy="685800"/>
           </a:xfrm>
           <a:prstGeom prst="roundRect">
             <a:avLst>
-              <a:gd name="adj" fmla="val 8696"/>
+              <a:gd name="adj" fmla="val 13333"/>
             </a:avLst>
           </a:prstGeom>
           <a:solidFill>
-            <a:srgbClr val="FFFFFF"/>
+            <a:srgbClr val="E8EBF0"/>
           </a:solidFill>
           <a:ln/>
-          <a:effectLst>
-            <a:outerShdw sx="100000" sy="100000" kx="0" ky="0" algn="bl" rotWithShape="0" blurRad="63500" dist="25400" dir="5400000">
-              <a:srgbClr val="DDDDDD">
-                <a:alpha val="30000"/>
-              </a:srgbClr>
-            </a:outerShdw>
-          </a:effectLst>
-        </p:spPr>
-      </p:sp>
-      <p:sp>
-        <p:nvSpPr>
-          <p:cNvPr id="22" name="Shape 20"/>
-          <p:cNvSpPr/>
-          <p:nvPr/>
-        </p:nvSpPr>
-        <p:spPr>
-          <a:xfrm>
-            <a:off x="914400" y="4572000"/>
-            <a:ext cx="640080" cy="640080"/>
-          </a:xfrm>
-          <a:prstGeom prst="ellipse">
-            <a:avLst/>
-          </a:prstGeom>
-          <a:solidFill>
-            <a:srgbClr val="27AE60"/>
-          </a:solidFill>
-          <a:ln/>
-        </p:spPr>
-      </p:sp>
-      <p:sp>
-        <p:nvSpPr>
-          <p:cNvPr id="23" name="Text 21"/>
-          <p:cNvSpPr txBox="1"/>
-          <p:nvPr/>
-        </p:nvSpPr>
-        <p:spPr>
-          <a:xfrm>
-            <a:off x="914400" y="4590288"/>
-            <a:ext cx="640080" cy="594360"/>
-          </a:xfrm>
-          <a:prstGeom prst="rect">
-            <a:avLst/>
-          </a:prstGeom>
-          <a:noFill/>
-          <a:ln/>
-        </p:spPr>
-        <p:txBody>
-          <a:bodyPr wrap="square" lIns="0" tIns="0" rIns="0" bIns="0" rtlCol="0" anchor="ctr"/>
-          <a:lstStyle/>
-          <a:p>
-            <a:pPr algn="ctr" indent="0" marL="0">
-              <a:buNone/>
-            </a:pPr>
-            <a:r>
-              <a:rPr lang="en-US" sz="2800" b="1" dirty="0">
-                <a:solidFill>
-                  <a:srgbClr val="FFFFFF"/>
+        </p:spPr>
+      </p:sp>
+      <p:sp>
+        <p:nvSpPr>
+          <p:cNvPr id="22" name="Text 20"/>
+          <p:cNvSpPr txBox="1"/>
+          <p:nvPr/>
+        </p:nvSpPr>
+        <p:spPr>
+          <a:xfrm>
+            <a:off x="1005840" y="5257800"/>
+            <a:ext cx="2743200" cy="228600"/>
+          </a:xfrm>
+          <a:prstGeom prst="rect">
+            <a:avLst/>
+          </a:prstGeom>
+          <a:noFill/>
+          <a:ln/>
+        </p:spPr>
+        <p:txBody>
+          <a:bodyPr wrap="square" lIns="0" tIns="0" rIns="0" bIns="0" rtlCol="0" anchor="ctr"/>
+          <a:lstStyle/>
+          <a:p>
+            <a:pPr indent="0" marL="0">
+              <a:buNone/>
+            </a:pPr>
+            <a:r>
+              <a:rPr lang="en-US" sz="1200" b="1" dirty="0">
+                <a:solidFill>
+                  <a:srgbClr val="1B2A4A"/>
                 </a:solidFill>
                 <a:latin typeface="Calibri" pitchFamily="34" charset="0"/>
                 <a:ea typeface="Calibri" pitchFamily="34" charset="-122"/>
                 <a:cs typeface="Calibri" pitchFamily="34" charset="-120"/>
               </a:rPr>
-              <a:t>S</a:t>
-            </a:r>
-            <a:endParaRPr lang="en-US" sz="2800" dirty="0"/>
+              <a:t>Recrutement en Cours</a:t>
+            </a:r>
+            <a:endParaRPr lang="en-US" sz="1200" dirty="0"/>
+          </a:p>
+        </p:txBody>
+      </p:sp>
+      <p:sp>
+        <p:nvSpPr>
+          <p:cNvPr id="23" name="Text 21"/>
+          <p:cNvSpPr txBox="1"/>
+          <p:nvPr/>
+        </p:nvSpPr>
+        <p:spPr>
+          <a:xfrm>
+            <a:off x="1005840" y="5532120"/>
+            <a:ext cx="10241280" cy="274320"/>
+          </a:xfrm>
+          <a:prstGeom prst="rect">
+            <a:avLst/>
+          </a:prstGeom>
+          <a:noFill/>
+          <a:ln/>
+        </p:spPr>
+        <p:txBody>
+          <a:bodyPr wrap="square" lIns="0" tIns="0" rIns="0" bIns="0" rtlCol="0" anchor="ctr"/>
+          <a:lstStyle/>
+          <a:p>
+            <a:pPr indent="0" marL="0">
+              <a:buNone/>
+            </a:pPr>
+            <a:r>
+              <a:rPr lang="en-US" sz="1000" dirty="0">
+                <a:solidFill>
+                  <a:srgbClr val="6B7B8D"/>
+                </a:solidFill>
+                <a:latin typeface="Arial" pitchFamily="34" charset="0"/>
+                <a:ea typeface="Arial" pitchFamily="34" charset="-122"/>
+                <a:cs typeface="Arial" pitchFamily="34" charset="-120"/>
+              </a:rPr>
+              <a:t>Responsable Technique et Responsable Qualité — CV reçus, finalisation des entretiens prévue le 11 juillet 2026</a:t>
+            </a:r>
+            <a:endParaRPr lang="en-US" sz="1000" dirty="0"/>
           </a:p>
         </p:txBody>
       </p:sp>
       <p:sp>
         <p:nvSpPr>
           <p:cNvPr id="24" name="Text 22"/>
-          <p:cNvSpPr txBox="1"/>
-          <p:nvPr/>
-        </p:nvSpPr>
-        <p:spPr>
-          <a:xfrm>
-            <a:off x="1783080" y="4498848"/>
-            <a:ext cx="2743200" cy="320040"/>
-          </a:xfrm>
-          <a:prstGeom prst="rect">
-            <a:avLst/>
-          </a:prstGeom>
-          <a:noFill/>
-          <a:ln/>
-        </p:spPr>
-        <p:txBody>
-          <a:bodyPr wrap="square" lIns="0" tIns="0" rIns="0" bIns="0" rtlCol="0" anchor="ctr"/>
-          <a:lstStyle/>
-          <a:p>
-            <a:pPr indent="0" marL="0">
-              <a:buNone/>
-            </a:pPr>
-            <a:r>
-              <a:rPr lang="en-US" sz="1600" b="1" dirty="0">
-                <a:solidFill>
-                  <a:srgbClr val="1B2A4A"/>
-                </a:solidFill>
-                <a:latin typeface="Calibri" pitchFamily="34" charset="0"/>
-                <a:ea typeface="Calibri" pitchFamily="34" charset="-122"/>
-                <a:cs typeface="Calibri" pitchFamily="34" charset="-120"/>
-              </a:rPr>
-              <a:t>Soufiane Incendie</a:t>
-            </a:r>
-            <a:endParaRPr lang="en-US" sz="1600" dirty="0"/>
-          </a:p>
-        </p:txBody>
-      </p:sp>
-      <p:sp>
-        <p:nvSpPr>
-          <p:cNvPr id="25" name="Text 23"/>
-          <p:cNvSpPr txBox="1"/>
-          <p:nvPr/>
-        </p:nvSpPr>
-        <p:spPr>
-          <a:xfrm>
-            <a:off x="1783080" y="4800600"/>
-            <a:ext cx="2743200" cy="228600"/>
-          </a:xfrm>
-          <a:prstGeom prst="rect">
-            <a:avLst/>
-          </a:prstGeom>
-          <a:noFill/>
-          <a:ln/>
-        </p:spPr>
-        <p:txBody>
-          <a:bodyPr wrap="square" lIns="0" tIns="0" rIns="0" bIns="0" rtlCol="0" anchor="ctr"/>
-          <a:lstStyle/>
-          <a:p>
-            <a:pPr indent="0" marL="0">
-              <a:buNone/>
-            </a:pPr>
-            <a:r>
-              <a:rPr lang="en-US" sz="1100" dirty="0">
-                <a:solidFill>
-                  <a:srgbClr val="27AE60"/>
-                </a:solidFill>
-                <a:latin typeface="Arial" pitchFamily="34" charset="0"/>
-                <a:ea typeface="Arial" pitchFamily="34" charset="-122"/>
-                <a:cs typeface="Arial" pitchFamily="34" charset="-120"/>
-              </a:rPr>
-              <a:t>Fire Safety Provider</a:t>
-            </a:r>
-            <a:endParaRPr lang="en-US" sz="1100" dirty="0"/>
-          </a:p>
-        </p:txBody>
-      </p:sp>
-      <p:sp>
-        <p:nvSpPr>
-          <p:cNvPr id="26" name="Text 24"/>
-          <p:cNvSpPr txBox="1"/>
-          <p:nvPr/>
-        </p:nvSpPr>
-        <p:spPr>
-          <a:xfrm>
-            <a:off x="4754880" y="4526280"/>
-            <a:ext cx="6583680" cy="777240"/>
-          </a:xfrm>
-          <a:prstGeom prst="rect">
-            <a:avLst/>
-          </a:prstGeom>
-          <a:noFill/>
-          <a:ln/>
-        </p:spPr>
-        <p:txBody>
-          <a:bodyPr wrap="square" lIns="0" tIns="0" rIns="0" bIns="0" rtlCol="0" anchor="ctr"/>
-          <a:lstStyle/>
-          <a:p>
-            <a:pPr indent="0" marL="0">
-              <a:lnSpc>
-                <a:spcPct val="130000"/>
-              </a:lnSpc>
-              <a:buNone/>
-            </a:pPr>
-            <a:r>
-              <a:rPr lang="en-US" sz="1050" dirty="0">
-                <a:solidFill>
-                  <a:srgbClr val="6B7B8D"/>
-                </a:solidFill>
-                <a:latin typeface="Arial" pitchFamily="34" charset="0"/>
-                <a:ea typeface="Arial" pitchFamily="34" charset="-122"/>
-                <a:cs typeface="Arial" pitchFamily="34" charset="-120"/>
-              </a:rPr>
-              <a:t>Full NSI ERT dossier, PCI floor plans (ground &amp; 1st floor), pressurization system design, building modification authorizations.</a:t>
-            </a:r>
-            <a:endParaRPr lang="en-US" sz="1050" dirty="0"/>
-          </a:p>
-        </p:txBody>
-      </p:sp>
-      <p:sp>
-        <p:nvSpPr>
-          <p:cNvPr id="27" name="Shape 25"/>
-          <p:cNvSpPr/>
-          <p:nvPr/>
-        </p:nvSpPr>
-        <p:spPr>
-          <a:xfrm>
-            <a:off x="640080" y="5486400"/>
-            <a:ext cx="10927080" cy="594360"/>
-          </a:xfrm>
-          <a:prstGeom prst="roundRect">
-            <a:avLst>
-              <a:gd name="adj" fmla="val 15385"/>
-            </a:avLst>
-          </a:prstGeom>
-          <a:solidFill>
-            <a:srgbClr val="E8EBF0"/>
-          </a:solidFill>
-          <a:ln/>
-        </p:spPr>
-      </p:sp>
-      <p:sp>
-        <p:nvSpPr>
-          <p:cNvPr id="28" name="Text 26"/>
-          <p:cNvSpPr txBox="1"/>
-          <p:nvPr/>
-        </p:nvSpPr>
-        <p:spPr>
-          <a:xfrm>
-            <a:off x="1005840" y="5532120"/>
-            <a:ext cx="2743200" cy="228600"/>
-          </a:xfrm>
-          <a:prstGeom prst="rect">
-            <a:avLst/>
-          </a:prstGeom>
-          <a:noFill/>
-          <a:ln/>
-        </p:spPr>
-        <p:txBody>
-          <a:bodyPr wrap="square" lIns="0" tIns="0" rIns="0" bIns="0" rtlCol="0" anchor="ctr"/>
-          <a:lstStyle/>
-          <a:p>
-            <a:pPr indent="0" marL="0">
-              <a:buNone/>
-            </a:pPr>
-            <a:r>
-              <a:rPr lang="en-US" sz="1200" b="1" dirty="0">
-                <a:solidFill>
-                  <a:srgbClr val="1B2A4A"/>
-                </a:solidFill>
-                <a:latin typeface="Calibri" pitchFamily="34" charset="0"/>
-                <a:ea typeface="Calibri" pitchFamily="34" charset="-122"/>
-                <a:cs typeface="Calibri" pitchFamily="34" charset="-120"/>
-              </a:rPr>
-              <a:t>Recruitment in Progress</a:t>
-            </a:r>
-            <a:endParaRPr lang="en-US" sz="1200" dirty="0"/>
-          </a:p>
-        </p:txBody>
-      </p:sp>
-      <p:sp>
-        <p:nvSpPr>
-          <p:cNvPr id="29" name="Text 27"/>
-          <p:cNvSpPr txBox="1"/>
-          <p:nvPr/>
-        </p:nvSpPr>
-        <p:spPr>
-          <a:xfrm>
-            <a:off x="1005840" y="5760720"/>
-            <a:ext cx="10241280" cy="274320"/>
-          </a:xfrm>
-          <a:prstGeom prst="rect">
-            <a:avLst/>
-          </a:prstGeom>
-          <a:noFill/>
-          <a:ln/>
-        </p:spPr>
-        <p:txBody>
-          <a:bodyPr wrap="square" lIns="0" tIns="0" rIns="0" bIns="0" rtlCol="0" anchor="ctr"/>
-          <a:lstStyle/>
-          <a:p>
-            <a:pPr indent="0" marL="0">
-              <a:buNone/>
-            </a:pPr>
-            <a:r>
-              <a:rPr lang="en-US" sz="1000" dirty="0">
-                <a:solidFill>
-                  <a:srgbClr val="6B7B8D"/>
-                </a:solidFill>
-                <a:latin typeface="Arial" pitchFamily="34" charset="0"/>
-                <a:ea typeface="Arial" pitchFamily="34" charset="-122"/>
-                <a:cs typeface="Arial" pitchFamily="34" charset="-120"/>
-              </a:rPr>
-              <a:t>Technical Manager (Responsable Technique) and Quality Manager (Responsable Qualité) — CVs received, interview finalization by July 11, 2026</a:t>
-            </a:r>
-            <a:endParaRPr lang="en-US" sz="1000" dirty="0"/>
-          </a:p>
-        </p:txBody>
-      </p:sp>
-      <p:sp>
-        <p:nvSpPr>
-          <p:cNvPr id="30" name="Text 28"/>
           <p:cNvSpPr txBox="1"/>
           <p:nvPr/>
         </p:nvSpPr>
@@ -4458,7 +4250,7 @@
                 <a:ea typeface="Arial" pitchFamily="34" charset="-122"/>
                 <a:cs typeface="Arial" pitchFamily="34" charset="-120"/>
               </a:rPr>
-              <a:t>PetFactory Maroc  |  Investor Update  |  August 2026</a:t>
+              <a:t>PetFactory Maroc  |  Mise à jour Investisseurs  |  Août 2026</a:t>
             </a:r>
             <a:endParaRPr lang="en-US" sz="800" dirty="0"/>
           </a:p>
@@ -4549,7 +4341,7 @@
                 <a:ea typeface="Calibri" pitchFamily="34" charset="-122"/>
                 <a:cs typeface="Calibri" pitchFamily="34" charset="-120"/>
               </a:rPr>
-              <a:t>Next Steps</a:t>
+              <a:t>Prochaines Étapes</a:t>
             </a:r>
             <a:endParaRPr lang="en-US" sz="3600" dirty="0"/>
           </a:p>
@@ -4610,7 +4402,7 @@
                 <a:ea typeface="Calibri" pitchFamily="34" charset="-122"/>
                 <a:cs typeface="Calibri" pitchFamily="34" charset="-120"/>
               </a:rPr>
-              <a:t>Immediate (Jul 2026)</a:t>
+              <a:t>Immédiat (Juil. 2026)</a:t>
             </a:r>
             <a:endParaRPr lang="en-US" sz="1400" dirty="0"/>
           </a:p>
@@ -4669,7 +4461,7 @@
                 <a:ea typeface="Arial" pitchFamily="34" charset="-122"/>
                 <a:cs typeface="Arial" pitchFamily="34" charset="-120"/>
               </a:rPr>
-              <a:t>Unblock oil storage tank spec review (RED item)</a:t>
+              <a:t>Débloquer la revue spécification cuve huile (élément ROUGE)</a:t>
             </a:r>
             <a:endParaRPr lang="en-US" sz="1100" dirty="0"/>
           </a:p>
@@ -4728,7 +4520,7 @@
                 <a:ea typeface="Arial" pitchFamily="34" charset="-122"/>
                 <a:cs typeface="Arial" pitchFamily="34" charset="-120"/>
               </a:rPr>
-              <a:t>Mobilize civil works contractors for 5 overdue foundations</a:t>
+              <a:t>Mobiliser les entrepreneurs génie civil pour les 5 fondations en retard</a:t>
             </a:r>
             <a:endParaRPr lang="en-US" sz="1100" dirty="0"/>
           </a:p>
@@ -4787,7 +4579,7 @@
                 <a:ea typeface="Arial" pitchFamily="34" charset="-122"/>
                 <a:cs typeface="Arial" pitchFamily="34" charset="-120"/>
               </a:rPr>
-              <a:t>Finalize boiler, compressor, and elevator vendors by Jul 11</a:t>
+              <a:t>Finaliser les fournisseurs chaudière, compresseur et ascenseur d'ici le 11 juil.</a:t>
             </a:r>
             <a:endParaRPr lang="en-US" sz="1100" dirty="0"/>
           </a:p>
@@ -4848,7 +4640,7 @@
                 <a:ea typeface="Calibri" pitchFamily="34" charset="-122"/>
                 <a:cs typeface="Calibri" pitchFamily="34" charset="-120"/>
               </a:rPr>
-              <a:t>Near-term (Aug - Sep 2026)</a:t>
+              <a:t>Court terme (Août - Sept. 2026)</a:t>
             </a:r>
             <a:endParaRPr lang="en-US" sz="1400" dirty="0"/>
           </a:p>
@@ -4907,7 +4699,7 @@
                 <a:ea typeface="Arial" pitchFamily="34" charset="-122"/>
                 <a:cs typeface="Arial" pitchFamily="34" charset="-120"/>
               </a:rPr>
-              <a:t>Equipment manufacturing and quality inspections</a:t>
+              <a:t>Fabrication des équipements et inspections qualité</a:t>
             </a:r>
             <a:endParaRPr lang="en-US" sz="1100" dirty="0"/>
           </a:p>
@@ -4966,7 +4758,7 @@
                 <a:ea typeface="Arial" pitchFamily="34" charset="-122"/>
                 <a:cs typeface="Arial" pitchFamily="34" charset="-120"/>
               </a:rPr>
-              <a:t>Complete gas installation vendor selection</a:t>
+              <a:t>Finaliser la sélection du fournisseur gaz</a:t>
             </a:r>
             <a:endParaRPr lang="en-US" sz="1100" dirty="0"/>
           </a:p>
@@ -5025,7 +4817,7 @@
                 <a:ea typeface="Arial" pitchFamily="34" charset="-122"/>
                 <a:cs typeface="Arial" pitchFamily="34" charset="-120"/>
               </a:rPr>
-              <a:t>Initiate FAMSUN silo delivery schedule tracking</a:t>
+              <a:t>Lancer le suivi du calendrier de livraison des silos FAMSUN</a:t>
             </a:r>
             <a:endParaRPr lang="en-US" sz="1100" dirty="0"/>
           </a:p>
@@ -5086,7 +4878,7 @@
                 <a:ea typeface="Calibri" pitchFamily="34" charset="-122"/>
                 <a:cs typeface="Calibri" pitchFamily="34" charset="-120"/>
               </a:rPr>
-              <a:t>Pre-commissioning (Oct - Nov 2026)</a:t>
+              <a:t>Pré-mise en service (Oct. - Nov. 2026)</a:t>
             </a:r>
             <a:endParaRPr lang="en-US" sz="1400" dirty="0"/>
           </a:p>
@@ -5145,7 +4937,7 @@
                 <a:ea typeface="Arial" pitchFamily="34" charset="-122"/>
                 <a:cs typeface="Arial" pitchFamily="34" charset="-120"/>
               </a:rPr>
-              <a:t>All equipment delivered and installed on site</a:t>
+              <a:t>Tous les équipements livrés et installés sur site</a:t>
             </a:r>
             <a:endParaRPr lang="en-US" sz="1100" dirty="0"/>
           </a:p>
@@ -5204,7 +4996,7 @@
                 <a:ea typeface="Arial" pitchFamily="34" charset="-122"/>
                 <a:cs typeface="Arial" pitchFamily="34" charset="-120"/>
               </a:rPr>
-              <a:t>Systems testing and FAMSUN performance validation</a:t>
+              <a:t>Tests systèmes et validation des performances FAMSUN</a:t>
             </a:r>
             <a:endParaRPr lang="en-US" sz="1100" dirty="0"/>
           </a:p>
@@ -5263,7 +5055,7 @@
                 <a:ea typeface="Arial" pitchFamily="34" charset="-122"/>
                 <a:cs typeface="Arial" pitchFamily="34" charset="-120"/>
               </a:rPr>
-              <a:t>Target: Facility commissioned November 24, 2026</a:t>
+              <a:t>Objectif : Usine mise en service le 24 novembre 2026</a:t>
             </a:r>
             <a:endParaRPr lang="en-US" sz="1100" dirty="0"/>
           </a:p>
@@ -5341,7 +5133,7 @@
                 <a:ea typeface="Arial" pitchFamily="34" charset="-122"/>
                 <a:cs typeface="Arial" pitchFamily="34" charset="-120"/>
               </a:rPr>
-              <a:t>Confidential  |  For Investor Discussion Only</a:t>
+              <a:t>Confidentiel  |  Réservé aux discussions avec les investisseurs</a:t>
             </a:r>
             <a:endParaRPr lang="en-US" sz="1000" dirty="0"/>
           </a:p>
@@ -5412,7 +5204,7 @@
                 <a:ea typeface="Calibri" pitchFamily="34" charset="-122"/>
                 <a:cs typeface="Calibri" pitchFamily="34" charset="-120"/>
               </a:rPr>
-              <a:t>Executive Summary</a:t>
+              <a:t>Résumé Exécutif</a:t>
             </a:r>
             <a:endParaRPr lang="en-US" sz="3200" dirty="0"/>
           </a:p>
@@ -5454,7 +5246,7 @@
                 <a:ea typeface="Arial" pitchFamily="34" charset="-122"/>
                 <a:cs typeface="Arial" pitchFamily="34" charset="-120"/>
               </a:rPr>
-              <a:t>PetFactory Morocco is a greenfield premium pet food manufacturing platform, 100% owned by Petland Maroc. Engineered turnkey by FAMSUN with a 5 T/h dry extrusion line, the facility targets private-label and co-branded production for retailers across economy to super-premium tiers. Strategically located at Sidi Bouathmane near Casablanca port, with direct access to EU, US, Gulf and African markets.</a:t>
+              <a:t>PetFactory Maroc est une plateforme de fabrication d'aliments premium pour animaux, détenue à 100% par Petland Maroc. Conçue clé en main par FAMSUN avec une ligne d'extrusion sèche de 5 T/h, l'usine cible la production en marque blanche et co-marquée pour les distributeurs, de l'entrée de gamme au super-premium. Stratégiquement située à Sidi Bouathmane près du port de Casablanca, avec accès direct aux marchés UE, US, Golfe et Afrique.</a:t>
             </a:r>
             <a:endParaRPr lang="en-US" sz="1300" dirty="0"/>
           </a:p>
@@ -5561,7 +5353,7 @@
                 <a:ea typeface="Arial" pitchFamily="34" charset="-122"/>
                 <a:cs typeface="Arial" pitchFamily="34" charset="-120"/>
               </a:rPr>
-              <a:t>Extrusion Capacity</a:t>
+              <a:t>Capacité d'extrusion</a:t>
             </a:r>
             <a:endParaRPr lang="en-US" sz="1100" dirty="0"/>
           </a:p>
@@ -5668,7 +5460,7 @@
                 <a:ea typeface="Arial" pitchFamily="34" charset="-122"/>
                 <a:cs typeface="Arial" pitchFamily="34" charset="-120"/>
               </a:rPr>
-              <a:t>Infrastructure Systems</a:t>
+              <a:t>Systèmes d'infrastructure</a:t>
             </a:r>
             <a:endParaRPr lang="en-US" sz="1100" dirty="0"/>
           </a:p>
@@ -5736,7 +5528,7 @@
                 <a:ea typeface="Calibri" pitchFamily="34" charset="-122"/>
                 <a:cs typeface="Calibri" pitchFamily="34" charset="-120"/>
               </a:rPr>
-              <a:t>24.2%</a:t>
+              <a:t>24,2%</a:t>
             </a:r>
             <a:endParaRPr lang="en-US" sz="3600" dirty="0"/>
           </a:p>
@@ -5775,7 +5567,7 @@
                 <a:ea typeface="Arial" pitchFamily="34" charset="-122"/>
                 <a:cs typeface="Arial" pitchFamily="34" charset="-120"/>
               </a:rPr>
-              <a:t>Overall Progress</a:t>
+              <a:t>Avancement global</a:t>
             </a:r>
             <a:endParaRPr lang="en-US" sz="1100" dirty="0"/>
           </a:p>
@@ -5882,7 +5674,7 @@
                 <a:ea typeface="Arial" pitchFamily="34" charset="-122"/>
                 <a:cs typeface="Arial" pitchFamily="34" charset="-120"/>
               </a:rPr>
-              <a:t>Target Commissioning</a:t>
+              <a:t>Mise en service cible</a:t>
             </a:r>
             <a:endParaRPr lang="en-US" sz="1100" dirty="0"/>
           </a:p>
@@ -5921,7 +5713,7 @@
                 <a:ea typeface="Calibri" pitchFamily="34" charset="-122"/>
                 <a:cs typeface="Calibri" pitchFamily="34" charset="-120"/>
               </a:rPr>
-              <a:t>Key Highlights</a:t>
+              <a:t>Points clés</a:t>
             </a:r>
             <a:endParaRPr lang="en-US" sz="1800" dirty="0"/>
           </a:p>
@@ -5980,7 +5772,7 @@
                 <a:ea typeface="Arial" pitchFamily="34" charset="-122"/>
                 <a:cs typeface="Arial" pitchFamily="34" charset="-120"/>
               </a:rPr>
-              <a:t>JV with Normandie Pet Food (France)</a:t>
+              <a:t>Accord de libre-échange Maroc-USA</a:t>
             </a:r>
             <a:endParaRPr lang="en-US" sz="1200" dirty="0"/>
           </a:p>
@@ -6019,7 +5811,7 @@
                 <a:ea typeface="Arial" pitchFamily="34" charset="-122"/>
                 <a:cs typeface="Arial" pitchFamily="34" charset="-120"/>
               </a:rPr>
-              <a:t>EU market access, backed by Bpifrance &amp; Credit Agricole</a:t>
+              <a:t>Accès en franchise douanière, transit 7-12 jours côte Est</a:t>
             </a:r>
             <a:endParaRPr lang="en-US" sz="1100" dirty="0"/>
           </a:p>
@@ -6078,7 +5870,7 @@
                 <a:ea typeface="Arial" pitchFamily="34" charset="-122"/>
                 <a:cs typeface="Arial" pitchFamily="34" charset="-120"/>
               </a:rPr>
-              <a:t>US-Morocco Free Trade Agreement</a:t>
+              <a:t>HACCP &amp; ISO 22000 en cours</a:t>
             </a:r>
             <a:endParaRPr lang="en-US" sz="1200" dirty="0"/>
           </a:p>
@@ -6117,7 +5909,7 @@
                 <a:ea typeface="Arial" pitchFamily="34" charset="-122"/>
                 <a:cs typeface="Arial" pitchFamily="34" charset="-120"/>
               </a:rPr>
-              <a:t>Duty-free access, 7-12 day East Coast transit</a:t>
+              <a:t>Enregistrement FDA prévu ; traçabilité complète des lots</a:t>
             </a:r>
             <a:endParaRPr lang="en-US" sz="1100" dirty="0"/>
           </a:p>
@@ -6176,7 +5968,7 @@
                 <a:ea typeface="Arial" pitchFamily="34" charset="-122"/>
                 <a:cs typeface="Arial" pitchFamily="34" charset="-120"/>
               </a:rPr>
-              <a:t>HACCP &amp; ISO 22000 in implementation</a:t>
+              <a:t>Transformateur électrique — BC signé</a:t>
             </a:r>
             <a:endParaRPr lang="en-US" sz="1200" dirty="0"/>
           </a:p>
@@ -6215,7 +6007,7 @@
                 <a:ea typeface="Arial" pitchFamily="34" charset="-122"/>
                 <a:cs typeface="Arial" pitchFamily="34" charset="-120"/>
               </a:rPr>
-              <a:t>FDA registration planned; full batch traceability</a:t>
+              <a:t>1 600 KVA — fabrication démarrée juillet 2026</a:t>
             </a:r>
             <a:endParaRPr lang="en-US" sz="1100" dirty="0"/>
           </a:p>
@@ -6274,7 +6066,7 @@
                 <a:ea typeface="Arial" pitchFamily="34" charset="-122"/>
                 <a:cs typeface="Arial" pitchFamily="34" charset="-120"/>
               </a:rPr>
-              <a:t>Electrical transformer PO signed</a:t>
+              <a:t>Proximité ports UE, Golfe et Afrique</a:t>
             </a:r>
             <a:endParaRPr lang="en-US" sz="1200" dirty="0"/>
           </a:p>
@@ -6313,7 +6105,7 @@
                 <a:ea typeface="Arial" pitchFamily="34" charset="-122"/>
                 <a:cs typeface="Arial" pitchFamily="34" charset="-120"/>
               </a:rPr>
-              <a:t>1,600 KVA — manufacturing starts July 2026</a:t>
+              <a:t>Hub logistique Casablanca, accès multi-marchés</a:t>
             </a:r>
             <a:endParaRPr lang="en-US" sz="1100" dirty="0"/>
           </a:p>
@@ -6352,7 +6144,7 @@
                 <a:ea typeface="Arial" pitchFamily="34" charset="-122"/>
                 <a:cs typeface="Arial" pitchFamily="34" charset="-120"/>
               </a:rPr>
-              <a:t>PetFactory Maroc  |  Investor Update  |  August 2026</a:t>
+              <a:t>PetFactory Maroc  |  Mise à jour Investisseurs  |  Août 2026</a:t>
             </a:r>
             <a:endParaRPr lang="en-US" sz="800" dirty="0"/>
           </a:p>
@@ -6423,7 +6215,7 @@
                 <a:ea typeface="Calibri" pitchFamily="34" charset="-122"/>
                 <a:cs typeface="Calibri" pitchFamily="34" charset="-120"/>
               </a:rPr>
-              <a:t>Strategic Position</a:t>
+              <a:t>Position Stratégique</a:t>
             </a:r>
             <a:endParaRPr lang="en-US" sz="3200" dirty="0"/>
           </a:p>
@@ -6484,7 +6276,7 @@
                 <a:ea typeface="Calibri" pitchFamily="34" charset="-122"/>
                 <a:cs typeface="Calibri" pitchFamily="34" charset="-120"/>
               </a:rPr>
-              <a:t>Location Advantage</a:t>
+              <a:t>Avantage Géographique</a:t>
             </a:r>
             <a:endParaRPr lang="en-US" sz="1800" dirty="0"/>
           </a:p>
@@ -6543,7 +6335,7 @@
                 <a:ea typeface="Arial" pitchFamily="34" charset="-122"/>
                 <a:cs typeface="Arial" pitchFamily="34" charset="-120"/>
               </a:rPr>
-              <a:t>Sidi Bouathmane, Morocco</a:t>
+              <a:t>Sidi Bouathmane, Maroc</a:t>
             </a:r>
             <a:endParaRPr lang="en-US" sz="1200" dirty="0"/>
           </a:p>
@@ -6585,7 +6377,7 @@
                 <a:ea typeface="Arial" pitchFamily="34" charset="-122"/>
                 <a:cs typeface="Arial" pitchFamily="34" charset="-120"/>
               </a:rPr>
-              <a:t>Near Casablanca deep-water port, direct container services to NY/NJ, Norfolk, Savannah, Montreal</a:t>
+              <a:t>Près du port en eau profonde de Casablanca, services conteneurs directs vers NY/NJ, Norfolk, Savannah, Montréal</a:t>
             </a:r>
             <a:endParaRPr lang="en-US" sz="1000" dirty="0"/>
           </a:p>
@@ -6644,7 +6436,7 @@
                 <a:ea typeface="Arial" pitchFamily="34" charset="-122"/>
                 <a:cs typeface="Arial" pitchFamily="34" charset="-120"/>
               </a:rPr>
-              <a:t>US-Morocco FTA (since 2006)</a:t>
+              <a:t>ALE Maroc-USA (depuis 2006)</a:t>
             </a:r>
             <a:endParaRPr lang="en-US" sz="1200" dirty="0"/>
           </a:p>
@@ -6686,7 +6478,7 @@
                 <a:ea typeface="Arial" pitchFamily="34" charset="-122"/>
                 <a:cs typeface="Arial" pitchFamily="34" charset="-120"/>
               </a:rPr>
-              <a:t>Duty-free on qualifying goods. 7-12 days to US East Coast vs. 30+ days from Asia</a:t>
+              <a:t>Franchise douanière sur produits qualifiés. 7-12 jours vers la côte Est US vs. 30+ jours depuis l'Asie</a:t>
             </a:r>
             <a:endParaRPr lang="en-US" sz="1000" dirty="0"/>
           </a:p>
@@ -6745,7 +6537,7 @@
                 <a:ea typeface="Arial" pitchFamily="34" charset="-122"/>
                 <a:cs typeface="Arial" pitchFamily="34" charset="-120"/>
               </a:rPr>
-              <a:t>EU Proximity</a:t>
+              <a:t>Proximité UE</a:t>
             </a:r>
             <a:endParaRPr lang="en-US" sz="1200" dirty="0"/>
           </a:p>
@@ -6787,7 +6579,7 @@
                 <a:ea typeface="Arial" pitchFamily="34" charset="-122"/>
                 <a:cs typeface="Arial" pitchFamily="34" charset="-120"/>
               </a:rPr>
-              <a:t>JV with Normandie Pet Food targets EUR 300M revenue by 2030. Direct access to EU market</a:t>
+              <a:t>Accès direct au marché européen. Objectif CA 300 M EUR d'ici 2030</a:t>
             </a:r>
             <a:endParaRPr lang="en-US" sz="1000" dirty="0"/>
           </a:p>
@@ -6846,7 +6638,7 @@
                 <a:ea typeface="Arial" pitchFamily="34" charset="-122"/>
                 <a:cs typeface="Arial" pitchFamily="34" charset="-120"/>
               </a:rPr>
-              <a:t>MAD Currency Stability</a:t>
+              <a:t>Stabilité du MAD</a:t>
             </a:r>
             <a:endParaRPr lang="en-US" sz="1200" dirty="0"/>
           </a:p>
@@ -6888,7 +6680,7 @@
                 <a:ea typeface="Arial" pitchFamily="34" charset="-122"/>
                 <a:cs typeface="Arial" pitchFamily="34" charset="-120"/>
               </a:rPr>
-              <a:t>Pegged to EUR/USD basket — reliable for multi-year supply contracts</a:t>
+              <a:t>Indexé sur panier EUR/USD — fiable pour contrats d'approvisionnement pluriannuels</a:t>
             </a:r>
             <a:endParaRPr lang="en-US" sz="1000" dirty="0"/>
           </a:p>
@@ -6947,7 +6739,7 @@
                 <a:ea typeface="Arial" pitchFamily="34" charset="-122"/>
                 <a:cs typeface="Arial" pitchFamily="34" charset="-120"/>
               </a:rPr>
-              <a:t>Gulf &amp; Africa</a:t>
+              <a:t>Golfe &amp; Afrique</a:t>
             </a:r>
             <a:endParaRPr lang="en-US" sz="1200" dirty="0"/>
           </a:p>
@@ -6989,7 +6781,7 @@
                 <a:ea typeface="Arial" pitchFamily="34" charset="-122"/>
                 <a:cs typeface="Arial" pitchFamily="34" charset="-120"/>
               </a:rPr>
-              <a:t>Growing pet ownership markets accessible from Casablanca hub</a:t>
+              <a:t>Marchés en croissance pour animaux de compagnie, accessibles depuis le hub de Casablanca</a:t>
             </a:r>
             <a:endParaRPr lang="en-US" sz="1000" dirty="0"/>
           </a:p>
@@ -7050,7 +6842,7 @@
                 <a:ea typeface="Calibri" pitchFamily="34" charset="-122"/>
                 <a:cs typeface="Calibri" pitchFamily="34" charset="-120"/>
               </a:rPr>
-              <a:t>Target Markets</a:t>
+              <a:t>Marchés Cibles</a:t>
             </a:r>
             <a:endParaRPr lang="en-US" sz="1800" dirty="0"/>
           </a:p>
@@ -7131,7 +6923,7 @@
                 <a:ea typeface="Arial" pitchFamily="34" charset="-122"/>
                 <a:cs typeface="Arial" pitchFamily="34" charset="-120"/>
               </a:rPr>
-              <a:t>North America</a:t>
+              <a:t>Amérique du Nord</a:t>
             </a:r>
             <a:endParaRPr lang="en-US" sz="1300" dirty="0"/>
           </a:p>
@@ -7173,7 +6965,7 @@
                 <a:ea typeface="Arial" pitchFamily="34" charset="-122"/>
                 <a:cs typeface="Arial" pitchFamily="34" charset="-120"/>
               </a:rPr>
-              <a:t>2-3 anchor buyer partnerships</a:t>
+              <a:t>2-3 partenariats acheteurs clés</a:t>
             </a:r>
             <a:endParaRPr lang="en-US" sz="1000" dirty="0"/>
           </a:p>
@@ -7193,7 +6985,7 @@
                 <a:ea typeface="Arial" pitchFamily="34" charset="-122"/>
                 <a:cs typeface="Arial" pitchFamily="34" charset="-120"/>
               </a:rPr>
-              <a:t>Duty-free FTA access</a:t>
+              <a:t>Accès en franchise (ALE)</a:t>
             </a:r>
             <a:endParaRPr lang="en-US" sz="1000" dirty="0"/>
           </a:p>
@@ -7274,7 +7066,7 @@
                 <a:ea typeface="Arial" pitchFamily="34" charset="-122"/>
                 <a:cs typeface="Arial" pitchFamily="34" charset="-120"/>
               </a:rPr>
-              <a:t>European Union</a:t>
+              <a:t>Union Européenne</a:t>
             </a:r>
             <a:endParaRPr lang="en-US" sz="1300" dirty="0"/>
           </a:p>
@@ -7316,7 +7108,7 @@
                 <a:ea typeface="Arial" pitchFamily="34" charset="-122"/>
                 <a:cs typeface="Arial" pitchFamily="34" charset="-120"/>
               </a:rPr>
-              <a:t>Normandie Pet Food JV</a:t>
+              <a:t>Accès direct marché UE</a:t>
             </a:r>
             <a:endParaRPr lang="en-US" sz="1000" dirty="0"/>
           </a:p>
@@ -7336,7 +7128,7 @@
                 <a:ea typeface="Arial" pitchFamily="34" charset="-122"/>
                 <a:cs typeface="Arial" pitchFamily="34" charset="-120"/>
               </a:rPr>
-              <a:t>Bpifrance / Credit Agricole backed</a:t>
+              <a:t>Proximité géographique</a:t>
             </a:r>
             <a:endParaRPr lang="en-US" sz="1000" dirty="0"/>
           </a:p>
@@ -7417,7 +7209,7 @@
                 <a:ea typeface="Arial" pitchFamily="34" charset="-122"/>
                 <a:cs typeface="Arial" pitchFamily="34" charset="-120"/>
               </a:rPr>
-              <a:t>Gulf States</a:t>
+              <a:t>États du Golfe</a:t>
             </a:r>
             <a:endParaRPr lang="en-US" sz="1300" dirty="0"/>
           </a:p>
@@ -7459,7 +7251,7 @@
                 <a:ea typeface="Arial" pitchFamily="34" charset="-122"/>
                 <a:cs typeface="Arial" pitchFamily="34" charset="-120"/>
               </a:rPr>
-              <a:t>Premium pet food demand</a:t>
+              <a:t>Demande premium croissante</a:t>
             </a:r>
             <a:endParaRPr lang="en-US" sz="1000" dirty="0"/>
           </a:p>
@@ -7479,7 +7271,7 @@
                 <a:ea typeface="Arial" pitchFamily="34" charset="-122"/>
                 <a:cs typeface="Arial" pitchFamily="34" charset="-120"/>
               </a:rPr>
-              <a:t>Growing middle class</a:t>
+              <a:t>Classe moyenne en expansion</a:t>
             </a:r>
             <a:endParaRPr lang="en-US" sz="1000" dirty="0"/>
           </a:p>
@@ -7560,7 +7352,7 @@
                 <a:ea typeface="Arial" pitchFamily="34" charset="-122"/>
                 <a:cs typeface="Arial" pitchFamily="34" charset="-120"/>
               </a:rPr>
-              <a:t>Africa</a:t>
+              <a:t>Afrique</a:t>
             </a:r>
             <a:endParaRPr lang="en-US" sz="1300" dirty="0"/>
           </a:p>
@@ -7602,7 +7394,7 @@
                 <a:ea typeface="Arial" pitchFamily="34" charset="-122"/>
                 <a:cs typeface="Arial" pitchFamily="34" charset="-120"/>
               </a:rPr>
-              <a:t>Emerging pet ownership</a:t>
+              <a:t>Marché émergent animaux de compagnie</a:t>
             </a:r>
             <a:endParaRPr lang="en-US" sz="1000" dirty="0"/>
           </a:p>
@@ -7622,7 +7414,7 @@
                 <a:ea typeface="Arial" pitchFamily="34" charset="-122"/>
                 <a:cs typeface="Arial" pitchFamily="34" charset="-120"/>
               </a:rPr>
-              <a:t>Regional proximity</a:t>
+              <a:t>Proximité régionale</a:t>
             </a:r>
             <a:endParaRPr lang="en-US" sz="1000" dirty="0"/>
           </a:p>
@@ -7661,7 +7453,7 @@
                 <a:ea typeface="Arial" pitchFamily="34" charset="-122"/>
                 <a:cs typeface="Arial" pitchFamily="34" charset="-120"/>
               </a:rPr>
-              <a:t>Incoterms: </a:t>
+              <a:t>Incoterms : </a:t>
             </a:r>
             <a:pPr indent="0" marL="0">
               <a:buNone/>
@@ -7675,7 +7467,7 @@
                 <a:ea typeface="Arial" pitchFamily="34" charset="-122"/>
                 <a:cs typeface="Arial" pitchFamily="34" charset="-120"/>
               </a:rPr>
-              <a:t>FOB Casablanca (CIF/DDP available)   |   </a:t>
+              <a:t>FOB Casablanca (CIF/DDP disponible)   |   </a:t>
             </a:r>
             <a:pPr indent="0" marL="0">
               <a:buNone/>
@@ -7689,7 +7481,7 @@
                 <a:ea typeface="Arial" pitchFamily="34" charset="-122"/>
                 <a:cs typeface="Arial" pitchFamily="34" charset="-120"/>
               </a:rPr>
-              <a:t>MOQ: </a:t>
+              <a:t>QMC : </a:t>
             </a:r>
             <a:pPr indent="0" marL="0">
               <a:buNone/>
@@ -7703,7 +7495,7 @@
                 <a:ea typeface="Arial" pitchFamily="34" charset="-122"/>
                 <a:cs typeface="Arial" pitchFamily="34" charset="-120"/>
               </a:rPr>
-              <a:t>Full container (20-ft / 40-ft per SKU)   |   </a:t>
+              <a:t>Conteneur complet (20/40 pieds par SKU)   |   </a:t>
             </a:r>
             <a:pPr indent="0" marL="0">
               <a:buNone/>
@@ -7717,7 +7509,7 @@
                 <a:ea typeface="Arial" pitchFamily="34" charset="-122"/>
                 <a:cs typeface="Arial" pitchFamily="34" charset="-120"/>
               </a:rPr>
-              <a:t>Transit: </a:t>
+              <a:t>Transit : </a:t>
             </a:r>
             <a:pPr indent="0" marL="0">
               <a:buNone/>
@@ -7731,7 +7523,7 @@
                 <a:ea typeface="Arial" pitchFamily="34" charset="-122"/>
                 <a:cs typeface="Arial" pitchFamily="34" charset="-120"/>
               </a:rPr>
-              <a:t>10-14 days port-to-port US East Coast</a:t>
+              <a:t>10-14 jours port-à-port côte Est US</a:t>
             </a:r>
             <a:endParaRPr lang="en-US" sz="1000" dirty="0"/>
           </a:p>
@@ -7770,7 +7562,7 @@
                 <a:ea typeface="Arial" pitchFamily="34" charset="-122"/>
                 <a:cs typeface="Arial" pitchFamily="34" charset="-120"/>
               </a:rPr>
-              <a:t>PetFactory Maroc  |  Investor Update  |  August 2026</a:t>
+              <a:t>PetFactory Maroc  |  Mise à jour Investisseurs  |  Août 2026</a:t>
             </a:r>
             <a:endParaRPr lang="en-US" sz="800" dirty="0"/>
           </a:p>
@@ -7841,7 +7633,7 @@
                 <a:ea typeface="Calibri" pitchFamily="34" charset="-122"/>
                 <a:cs typeface="Calibri" pitchFamily="34" charset="-120"/>
               </a:rPr>
-              <a:t>Production Line</a:t>
+              <a:t>Ligne de Production</a:t>
             </a:r>
             <a:endParaRPr lang="en-US" sz="3200" dirty="0"/>
           </a:p>
@@ -7880,7 +7672,7 @@
                 <a:ea typeface="Arial" pitchFamily="34" charset="-122"/>
                 <a:cs typeface="Arial" pitchFamily="34" charset="-120"/>
               </a:rPr>
-              <a:t>FAMSUN Turnkey  |  5 T/h Dry Extrusion</a:t>
+              <a:t>FAMSUN Clé en main  |  Extrusion sèche 5 T/h</a:t>
             </a:r>
             <a:endParaRPr lang="en-US" sz="1400" dirty="0"/>
           </a:p>
@@ -7982,7 +7774,7 @@
                 <a:ea typeface="Calibri" pitchFamily="34" charset="-122"/>
                 <a:cs typeface="Calibri" pitchFamily="34" charset="-120"/>
               </a:rPr>
-              <a:t>Raw</a:t>
+              <a:t>Matières</a:t>
             </a:r>
             <a:endParaRPr lang="en-US" sz="1200" dirty="0"/>
           </a:p>
@@ -7999,7 +7791,7 @@
                 <a:ea typeface="Calibri" pitchFamily="34" charset="-122"/>
                 <a:cs typeface="Calibri" pitchFamily="34" charset="-120"/>
               </a:rPr>
-              <a:t>Materials</a:t>
+              <a:t>Premières</a:t>
             </a:r>
             <a:endParaRPr lang="en-US" sz="1200" dirty="0"/>
           </a:p>
@@ -8040,7 +7832,7 @@
                 <a:ea typeface="Arial" pitchFamily="34" charset="-122"/>
                 <a:cs typeface="Arial" pitchFamily="34" charset="-120"/>
               </a:rPr>
-              <a:t>10% moisture</a:t>
+              <a:t>10% humidité</a:t>
             </a:r>
             <a:endParaRPr lang="en-US" sz="900" dirty="0"/>
           </a:p>
@@ -8059,7 +7851,7 @@
                 <a:ea typeface="Arial" pitchFamily="34" charset="-122"/>
                 <a:cs typeface="Arial" pitchFamily="34" charset="-120"/>
               </a:rPr>
-              <a:t>25°C input</a:t>
+              <a:t>25°C entrée</a:t>
             </a:r>
             <a:endParaRPr lang="en-US" sz="900" dirty="0"/>
           </a:p>
@@ -8181,7 +7973,7 @@
                 <a:ea typeface="Calibri" pitchFamily="34" charset="-122"/>
                 <a:cs typeface="Calibri" pitchFamily="34" charset="-120"/>
               </a:rPr>
-              <a:t>Pre-</a:t>
+              <a:t>Pré-</a:t>
             </a:r>
             <a:endParaRPr lang="en-US" sz="1200" dirty="0"/>
           </a:p>
@@ -8198,7 +7990,7 @@
                 <a:ea typeface="Calibri" pitchFamily="34" charset="-122"/>
                 <a:cs typeface="Calibri" pitchFamily="34" charset="-120"/>
               </a:rPr>
-              <a:t>conditioner</a:t>
+              <a:t>conditionneur</a:t>
             </a:r>
             <a:endParaRPr lang="en-US" sz="1200" dirty="0"/>
           </a:p>
@@ -8239,7 +8031,7 @@
                 <a:ea typeface="Arial" pitchFamily="34" charset="-122"/>
                 <a:cs typeface="Arial" pitchFamily="34" charset="-120"/>
               </a:rPr>
-              <a:t>Steam 350 kg/h</a:t>
+              <a:t>Vapeur 350 kg/h</a:t>
             </a:r>
             <a:endParaRPr lang="en-US" sz="900" dirty="0"/>
           </a:p>
@@ -8258,7 +8050,7 @@
                 <a:ea typeface="Arial" pitchFamily="34" charset="-122"/>
                 <a:cs typeface="Arial" pitchFamily="34" charset="-120"/>
               </a:rPr>
-              <a:t>Water 400 kg/h</a:t>
+              <a:t>Eau 400 kg/h</a:t>
             </a:r>
             <a:endParaRPr lang="en-US" sz="900" dirty="0"/>
           </a:p>
@@ -8380,7 +8172,7 @@
                 <a:ea typeface="Calibri" pitchFamily="34" charset="-122"/>
                 <a:cs typeface="Calibri" pitchFamily="34" charset="-120"/>
               </a:rPr>
-              <a:t>Extruder</a:t>
+              <a:t>Extrudeuse</a:t>
             </a:r>
             <a:endParaRPr lang="en-US" sz="1200" dirty="0"/>
           </a:p>
@@ -8438,7 +8230,7 @@
                 <a:ea typeface="Arial" pitchFamily="34" charset="-122"/>
                 <a:cs typeface="Arial" pitchFamily="34" charset="-120"/>
               </a:rPr>
-              <a:t>203 kW motor</a:t>
+              <a:t>Moteur 203 kW</a:t>
             </a:r>
             <a:endParaRPr lang="en-US" sz="900" dirty="0"/>
           </a:p>
@@ -8457,7 +8249,7 @@
                 <a:ea typeface="Arial" pitchFamily="34" charset="-122"/>
                 <a:cs typeface="Arial" pitchFamily="34" charset="-120"/>
               </a:rPr>
-              <a:t>145°C barrel</a:t>
+              <a:t>Fourreau 145°C</a:t>
             </a:r>
             <a:endParaRPr lang="en-US" sz="900" dirty="0"/>
           </a:p>
@@ -8579,7 +8371,7 @@
                 <a:ea typeface="Calibri" pitchFamily="34" charset="-122"/>
                 <a:cs typeface="Calibri" pitchFamily="34" charset="-120"/>
               </a:rPr>
-              <a:t>Dryer</a:t>
+              <a:t>Séchoir</a:t>
             </a:r>
             <a:endParaRPr lang="en-US" sz="1200" dirty="0"/>
           </a:p>
@@ -8637,7 +8429,7 @@
                 <a:ea typeface="Arial" pitchFamily="34" charset="-122"/>
                 <a:cs typeface="Arial" pitchFamily="34" charset="-120"/>
               </a:rPr>
-              <a:t>140°C inlet</a:t>
+              <a:t>Entrée 140°C</a:t>
             </a:r>
             <a:endParaRPr lang="en-US" sz="900" dirty="0"/>
           </a:p>
@@ -8656,7 +8448,7 @@
                 <a:ea typeface="Arial" pitchFamily="34" charset="-122"/>
                 <a:cs typeface="Arial" pitchFamily="34" charset="-120"/>
               </a:rPr>
-              <a:t>44 m² belt</a:t>
+              <a:t>Tapis 44 m²</a:t>
             </a:r>
             <a:endParaRPr lang="en-US" sz="900" dirty="0"/>
           </a:p>
@@ -8778,7 +8570,7 @@
                 <a:ea typeface="Calibri" pitchFamily="34" charset="-122"/>
                 <a:cs typeface="Calibri" pitchFamily="34" charset="-120"/>
               </a:rPr>
-              <a:t>Cooler</a:t>
+              <a:t>Refroidisseur</a:t>
             </a:r>
             <a:endParaRPr lang="en-US" sz="1200" dirty="0"/>
           </a:p>
@@ -8838,7 +8630,7 @@
                 <a:ea typeface="Arial" pitchFamily="34" charset="-122"/>
                 <a:cs typeface="Arial" pitchFamily="34" charset="-120"/>
               </a:rPr>
-              <a:t>residence time</a:t>
+              <a:t>temps de séjour</a:t>
             </a:r>
             <a:endParaRPr lang="en-US" sz="900" dirty="0"/>
           </a:p>
@@ -8960,7 +8752,7 @@
                 <a:ea typeface="Calibri" pitchFamily="34" charset="-122"/>
                 <a:cs typeface="Calibri" pitchFamily="34" charset="-120"/>
               </a:rPr>
-              <a:t>Coater</a:t>
+              <a:t>Enrobeur</a:t>
             </a:r>
             <a:endParaRPr lang="en-US" sz="1200" dirty="0"/>
           </a:p>
@@ -9001,7 +8793,7 @@
                 <a:ea typeface="Arial" pitchFamily="34" charset="-122"/>
                 <a:cs typeface="Arial" pitchFamily="34" charset="-120"/>
               </a:rPr>
-              <a:t>12% fat</a:t>
+              <a:t>12% matière grasse</a:t>
             </a:r>
             <a:endParaRPr lang="en-US" sz="900" dirty="0"/>
           </a:p>
@@ -9020,7 +8812,7 @@
                 <a:ea typeface="Arial" pitchFamily="34" charset="-122"/>
                 <a:cs typeface="Arial" pitchFamily="34" charset="-120"/>
               </a:rPr>
-              <a:t>2% palatant</a:t>
+              <a:t>2% appétent</a:t>
             </a:r>
             <a:endParaRPr lang="en-US" sz="900" dirty="0"/>
           </a:p>
@@ -9142,7 +8934,7 @@
                 <a:ea typeface="Calibri" pitchFamily="34" charset="-122"/>
                 <a:cs typeface="Calibri" pitchFamily="34" charset="-120"/>
               </a:rPr>
-              <a:t>Packaging</a:t>
+              <a:t>Conditionnement</a:t>
             </a:r>
             <a:endParaRPr lang="en-US" sz="1200" dirty="0"/>
           </a:p>
@@ -9183,7 +8975,7 @@
                 <a:ea typeface="Arial" pitchFamily="34" charset="-122"/>
                 <a:cs typeface="Arial" pitchFamily="34" charset="-120"/>
               </a:rPr>
-              <a:t>20°C room</a:t>
+              <a:t>Salle à 20°C</a:t>
             </a:r>
             <a:endParaRPr lang="en-US" sz="900" dirty="0"/>
           </a:p>
@@ -9202,7 +8994,7 @@
                 <a:ea typeface="Arial" pitchFamily="34" charset="-122"/>
                 <a:cs typeface="Arial" pitchFamily="34" charset="-120"/>
               </a:rPr>
-              <a:t>45% RH</a:t>
+              <a:t>45% HR</a:t>
             </a:r>
             <a:endParaRPr lang="en-US" sz="900" dirty="0"/>
           </a:p>
@@ -9263,7 +9055,7 @@
                 <a:ea typeface="Calibri" pitchFamily="34" charset="-122"/>
                 <a:cs typeface="Calibri" pitchFamily="34" charset="-120"/>
               </a:rPr>
-              <a:t>Guaranteed Performance</a:t>
+              <a:t>Performances Garanties</a:t>
             </a:r>
             <a:endParaRPr lang="en-US" sz="1600" dirty="0"/>
           </a:p>
@@ -9302,7 +9094,7 @@
                 <a:ea typeface="Arial" pitchFamily="34" charset="-122"/>
                 <a:cs typeface="Arial" pitchFamily="34" charset="-120"/>
               </a:rPr>
-              <a:t>Dog food (8.0 mm kibble)</a:t>
+              <a:t>Aliment chien (croquette 8,0 mm)</a:t>
             </a:r>
             <a:endParaRPr lang="en-US" sz="1100" dirty="0"/>
           </a:p>
@@ -9341,7 +9133,7 @@
                 <a:ea typeface="Arial" pitchFamily="34" charset="-122"/>
                 <a:cs typeface="Arial" pitchFamily="34" charset="-120"/>
               </a:rPr>
-              <a:t>≥ 5.0 T/h</a:t>
+              <a:t>≥ 5,0 T/h</a:t>
             </a:r>
             <a:endParaRPr lang="en-US" sz="1200" dirty="0"/>
           </a:p>
@@ -9380,7 +9172,7 @@
                 <a:ea typeface="Arial" pitchFamily="34" charset="-122"/>
                 <a:cs typeface="Arial" pitchFamily="34" charset="-120"/>
               </a:rPr>
-              <a:t>Cat food (4.0 mm kibble)</a:t>
+              <a:t>Aliment chat (croquette 4,0 mm)</a:t>
             </a:r>
             <a:endParaRPr lang="en-US" sz="1100" dirty="0"/>
           </a:p>
@@ -9419,7 +9211,7 @@
                 <a:ea typeface="Arial" pitchFamily="34" charset="-122"/>
                 <a:cs typeface="Arial" pitchFamily="34" charset="-120"/>
               </a:rPr>
-              <a:t>≥ 4.5 T/h</a:t>
+              <a:t>≥ 4,5 T/h</a:t>
             </a:r>
             <a:endParaRPr lang="en-US" sz="1200" dirty="0"/>
           </a:p>
@@ -9458,7 +9250,7 @@
                 <a:ea typeface="Arial" pitchFamily="34" charset="-122"/>
                 <a:cs typeface="Arial" pitchFamily="34" charset="-120"/>
               </a:rPr>
-              <a:t>Bulk density</a:t>
+              <a:t>Densité apparente</a:t>
             </a:r>
             <a:endParaRPr lang="en-US" sz="1100" dirty="0"/>
           </a:p>
@@ -9536,7 +9328,7 @@
                 <a:ea typeface="Arial" pitchFamily="34" charset="-122"/>
                 <a:cs typeface="Arial" pitchFamily="34" charset="-120"/>
               </a:rPr>
-              <a:t>Moisture target</a:t>
+              <a:t>Humidité cible</a:t>
             </a:r>
             <a:endParaRPr lang="en-US" sz="1100" dirty="0"/>
           </a:p>
@@ -9575,7 +9367,7 @@
                 <a:ea typeface="Arial" pitchFamily="34" charset="-122"/>
                 <a:cs typeface="Arial" pitchFamily="34" charset="-120"/>
               </a:rPr>
-              <a:t>9.0%</a:t>
+              <a:t>9,0%</a:t>
             </a:r>
             <a:endParaRPr lang="en-US" sz="1200" dirty="0"/>
           </a:p>
@@ -9614,7 +9406,7 @@
                 <a:ea typeface="Arial" pitchFamily="34" charset="-122"/>
                 <a:cs typeface="Arial" pitchFamily="34" charset="-120"/>
               </a:rPr>
-              <a:t>Water activity limit</a:t>
+              <a:t>Activité de l'eau limite</a:t>
             </a:r>
             <a:endParaRPr lang="en-US" sz="1100" dirty="0"/>
           </a:p>
@@ -9653,7 +9445,7 @@
                 <a:ea typeface="Arial" pitchFamily="34" charset="-122"/>
                 <a:cs typeface="Arial" pitchFamily="34" charset="-120"/>
               </a:rPr>
-              <a:t>≤ 0.60</a:t>
+              <a:t>≤ 0,60</a:t>
             </a:r>
             <a:endParaRPr lang="en-US" sz="1200" dirty="0"/>
           </a:p>
@@ -9714,7 +9506,7 @@
                 <a:ea typeface="Calibri" pitchFamily="34" charset="-122"/>
                 <a:cs typeface="Calibri" pitchFamily="34" charset="-120"/>
               </a:rPr>
-              <a:t>Product Range</a:t>
+              <a:t>Gamme de Produits</a:t>
             </a:r>
             <a:endParaRPr lang="en-US" sz="1600" dirty="0"/>
           </a:p>
@@ -9773,7 +9565,7 @@
                 <a:ea typeface="Arial" pitchFamily="34" charset="-122"/>
                 <a:cs typeface="Arial" pitchFamily="34" charset="-120"/>
               </a:rPr>
-              <a:t>Premium dry kibble (dog &amp; cat)</a:t>
+              <a:t>Croquettes premium sèches (chien &amp; chat)</a:t>
             </a:r>
             <a:endParaRPr lang="en-US" sz="1100" dirty="0"/>
           </a:p>
@@ -9832,7 +9624,7 @@
                 <a:ea typeface="Arial" pitchFamily="34" charset="-122"/>
                 <a:cs typeface="Arial" pitchFamily="34" charset="-120"/>
               </a:rPr>
-              <a:t>Custom formulations (shape, density, coating)</a:t>
+              <a:t>Formulations sur mesure (forme, densité, enrobage)</a:t>
             </a:r>
             <a:endParaRPr lang="en-US" sz="1100" dirty="0"/>
           </a:p>
@@ -9891,7 +9683,7 @@
                 <a:ea typeface="Arial" pitchFamily="34" charset="-122"/>
                 <a:cs typeface="Arial" pitchFamily="34" charset="-120"/>
               </a:rPr>
-              <a:t>Grain-free &amp; single-protein formats</a:t>
+              <a:t>Formats sans céréales &amp; protéine unique</a:t>
             </a:r>
             <a:endParaRPr lang="en-US" sz="1100" dirty="0"/>
           </a:p>
@@ -9950,7 +9742,7 @@
                 <a:ea typeface="Arial" pitchFamily="34" charset="-122"/>
                 <a:cs typeface="Arial" pitchFamily="34" charset="-120"/>
               </a:rPr>
-              <a:t>Prescription-style diets</a:t>
+              <a:t>Régimes de type vétérinaire</a:t>
             </a:r>
             <a:endParaRPr lang="en-US" sz="1100" dirty="0"/>
           </a:p>
@@ -10009,7 +9801,7 @@
                 <a:ea typeface="Arial" pitchFamily="34" charset="-122"/>
                 <a:cs typeface="Arial" pitchFamily="34" charset="-120"/>
               </a:rPr>
-              <a:t>Phase 2: Wet line (pate, chunks-in-gravy, treats)</a:t>
+              <a:t>Phase 2 : Ligne humide (pâté, morceaux en sauce, friandises)</a:t>
             </a:r>
             <a:endParaRPr lang="en-US" sz="1100" dirty="0"/>
           </a:p>
@@ -10048,7 +9840,7 @@
                 <a:ea typeface="Arial" pitchFamily="34" charset="-122"/>
                 <a:cs typeface="Arial" pitchFamily="34" charset="-120"/>
               </a:rPr>
-              <a:t>PetFactory Maroc  |  Investor Update  |  August 2026</a:t>
+              <a:t>PetFactory Maroc  |  Mise à jour Investisseurs  |  Août 2026</a:t>
             </a:r>
             <a:endParaRPr lang="en-US" sz="800" dirty="0"/>
           </a:p>
@@ -10119,7 +9911,7 @@
                 <a:ea typeface="Calibri" pitchFamily="34" charset="-122"/>
                 <a:cs typeface="Calibri" pitchFamily="34" charset="-120"/>
               </a:rPr>
-              <a:t>Infrastructure Systems</a:t>
+              <a:t>Systèmes d'Infrastructure</a:t>
             </a:r>
             <a:endParaRPr lang="en-US" sz="3200" dirty="0"/>
           </a:p>
@@ -10158,7 +9950,7 @@
                 <a:ea typeface="Arial" pitchFamily="34" charset="-122"/>
                 <a:cs typeface="Arial" pitchFamily="34" charset="-120"/>
               </a:rPr>
-              <a:t>14 Systems Tracked  |  128 Tasks  |  24.2% Overall Progress</a:t>
+              <a:t>14 systèmes suivis  |  128 tâches  |  24,2% d'avancement global</a:t>
             </a:r>
             <a:endParaRPr lang="en-US" sz="1400" dirty="0"/>
           </a:p>
@@ -10265,7 +10057,7 @@
                 <a:ea typeface="Arial" pitchFamily="34" charset="-122"/>
                 <a:cs typeface="Arial" pitchFamily="34" charset="-120"/>
               </a:rPr>
-              <a:t>Tasks Complete</a:t>
+              <a:t>Tâches terminées</a:t>
             </a:r>
             <a:endParaRPr lang="en-US" sz="1100" dirty="0"/>
           </a:p>
@@ -10372,7 +10164,7 @@
                 <a:ea typeface="Arial" pitchFamily="34" charset="-122"/>
                 <a:cs typeface="Arial" pitchFamily="34" charset="-120"/>
               </a:rPr>
-              <a:t>In Progress</a:t>
+              <a:t>En cours</a:t>
             </a:r>
             <a:endParaRPr lang="en-US" sz="1100" dirty="0"/>
           </a:p>
@@ -10479,7 +10271,7 @@
                 <a:ea typeface="Arial" pitchFamily="34" charset="-122"/>
                 <a:cs typeface="Arial" pitchFamily="34" charset="-120"/>
               </a:rPr>
-              <a:t>Not Started</a:t>
+              <a:t>Non démarrées</a:t>
             </a:r>
             <a:endParaRPr lang="en-US" sz="1100" dirty="0"/>
           </a:p>
@@ -10586,7 +10378,7 @@
                 <a:ea typeface="Arial" pitchFamily="34" charset="-122"/>
                 <a:cs typeface="Arial" pitchFamily="34" charset="-120"/>
               </a:rPr>
-              <a:t>Milestones Passed</a:t>
+              <a:t>Jalons atteints</a:t>
             </a:r>
             <a:endParaRPr lang="en-US" sz="1100" dirty="0"/>
           </a:p>
@@ -10647,7 +10439,7 @@
                 <a:ea typeface="Calibri" pitchFamily="34" charset="-122"/>
                 <a:cs typeface="Calibri" pitchFamily="34" charset="-120"/>
               </a:rPr>
-              <a:t>24.2%</a:t>
+              <a:t>24,2%</a:t>
             </a:r>
             <a:endParaRPr lang="en-US" sz="2400" dirty="0"/>
           </a:p>
@@ -10750,7 +10542,7 @@
                 <a:ea typeface="Arial" pitchFamily="34" charset="-122"/>
                 <a:cs typeface="Arial" pitchFamily="34" charset="-120"/>
               </a:rPr>
-              <a:t>System</a:t>
+              <a:t>Système</a:t>
             </a:r>
             <a:endParaRPr lang="en-US" sz="900" dirty="0"/>
           </a:p>
@@ -10789,7 +10581,7 @@
                 <a:ea typeface="Arial" pitchFamily="34" charset="-122"/>
                 <a:cs typeface="Arial" pitchFamily="34" charset="-120"/>
               </a:rPr>
-              <a:t>Specification</a:t>
+              <a:t>Spécification</a:t>
             </a:r>
             <a:endParaRPr lang="en-US" sz="900" dirty="0"/>
           </a:p>
@@ -10828,7 +10620,7 @@
                 <a:ea typeface="Arial" pitchFamily="34" charset="-122"/>
                 <a:cs typeface="Arial" pitchFamily="34" charset="-120"/>
               </a:rPr>
-              <a:t>Progress</a:t>
+              <a:t>Avancement</a:t>
             </a:r>
             <a:endParaRPr lang="en-US" sz="900" dirty="0"/>
           </a:p>
@@ -10867,7 +10659,7 @@
                 <a:ea typeface="Arial" pitchFamily="34" charset="-122"/>
                 <a:cs typeface="Arial" pitchFamily="34" charset="-120"/>
               </a:rPr>
-              <a:t>Status</a:t>
+              <a:t>Statut</a:t>
             </a:r>
             <a:endParaRPr lang="en-US" sz="900" dirty="0"/>
           </a:p>
@@ -10906,7 +10698,7 @@
                 <a:ea typeface="Arial" pitchFamily="34" charset="-122"/>
                 <a:cs typeface="Arial" pitchFamily="34" charset="-120"/>
               </a:rPr>
-              <a:t>Note</a:t>
+              <a:t>Remarque</a:t>
             </a:r>
             <a:endParaRPr lang="en-US" sz="900" dirty="0"/>
           </a:p>
@@ -10965,7 +10757,7 @@
                 <a:ea typeface="Arial" pitchFamily="34" charset="-122"/>
                 <a:cs typeface="Arial" pitchFamily="34" charset="-120"/>
               </a:rPr>
-              <a:t>Electrical &amp; Transformer</a:t>
+              <a:t>Électricité &amp; Transformateur</a:t>
             </a:r>
             <a:endParaRPr lang="en-US" sz="900" dirty="0"/>
           </a:p>
@@ -11004,7 +10796,7 @@
                 <a:ea typeface="Arial" pitchFamily="34" charset="-122"/>
                 <a:cs typeface="Arial" pitchFamily="34" charset="-120"/>
               </a:rPr>
-              <a:t>1,600 KVA</a:t>
+              <a:t>1 600 KVA</a:t>
             </a:r>
             <a:endParaRPr lang="en-US" sz="900" dirty="0"/>
           </a:p>
@@ -11146,7 +10938,7 @@
                 <a:ea typeface="Arial" pitchFamily="34" charset="-122"/>
                 <a:cs typeface="Arial" pitchFamily="34" charset="-120"/>
               </a:rPr>
-              <a:t>PO signed. Mfg starts Jul 1</a:t>
+              <a:t>BC signé. Fabrication démarre 1er juil.</a:t>
             </a:r>
             <a:endParaRPr lang="en-US" sz="800" dirty="0"/>
           </a:p>
@@ -11205,7 +10997,7 @@
                 <a:ea typeface="Arial" pitchFamily="34" charset="-122"/>
                 <a:cs typeface="Arial" pitchFamily="34" charset="-120"/>
               </a:rPr>
-              <a:t>Control Room &amp; MCC</a:t>
+              <a:t>Salle de contrôle &amp; TGBT</a:t>
             </a:r>
             <a:endParaRPr lang="en-US" sz="900" dirty="0"/>
           </a:p>
@@ -11244,7 +11036,7 @@
                 <a:ea typeface="Arial" pitchFamily="34" charset="-122"/>
                 <a:cs typeface="Arial" pitchFamily="34" charset="-120"/>
               </a:rPr>
-              <a:t>Separation</a:t>
+              <a:t>Séparation</a:t>
             </a:r>
             <a:endParaRPr lang="en-US" sz="900" dirty="0"/>
           </a:p>
@@ -11386,7 +11178,7 @@
                 <a:ea typeface="Arial" pitchFamily="34" charset="-122"/>
                 <a:cs typeface="Arial" pitchFamily="34" charset="-120"/>
               </a:rPr>
-              <a:t>Specs &amp; drawings approved</a:t>
+              <a:t>Spécifications &amp; plans approuvés</a:t>
             </a:r>
             <a:endParaRPr lang="en-US" sz="800" dirty="0"/>
           </a:p>
@@ -11445,7 +11237,7 @@
                 <a:ea typeface="Arial" pitchFamily="34" charset="-122"/>
                 <a:cs typeface="Arial" pitchFamily="34" charset="-120"/>
               </a:rPr>
-              <a:t>Exterior Concrete Works</a:t>
+              <a:t>Travaux béton extérieurs</a:t>
             </a:r>
             <a:endParaRPr lang="en-US" sz="900" dirty="0"/>
           </a:p>
@@ -11626,7 +11418,7 @@
                 <a:ea typeface="Arial" pitchFamily="34" charset="-122"/>
                 <a:cs typeface="Arial" pitchFamily="34" charset="-120"/>
               </a:rPr>
-              <a:t>Vendor finalization in progress</a:t>
+              <a:t>Finalisation fournisseur en cours</a:t>
             </a:r>
             <a:endParaRPr lang="en-US" sz="800" dirty="0"/>
           </a:p>
@@ -11685,7 +11477,7 @@
                 <a:ea typeface="Arial" pitchFamily="34" charset="-122"/>
                 <a:cs typeface="Arial" pitchFamily="34" charset="-120"/>
               </a:rPr>
-              <a:t>Industrial Cold</a:t>
+              <a:t>Froid industriel</a:t>
             </a:r>
             <a:endParaRPr lang="en-US" sz="900" dirty="0"/>
           </a:p>
@@ -11724,7 +11516,7 @@
                 <a:ea typeface="Arial" pitchFamily="34" charset="-122"/>
                 <a:cs typeface="Arial" pitchFamily="34" charset="-120"/>
               </a:rPr>
-              <a:t>Dry separation</a:t>
+              <a:t>Séparation sèche</a:t>
             </a:r>
             <a:endParaRPr lang="en-US" sz="900" dirty="0"/>
           </a:p>
@@ -11866,7 +11658,7 @@
                 <a:ea typeface="Arial" pitchFamily="34" charset="-122"/>
                 <a:cs typeface="Arial" pitchFamily="34" charset="-120"/>
               </a:rPr>
-              <a:t>Spec review complete</a:t>
+              <a:t>Revue des spécifications terminée</a:t>
             </a:r>
             <a:endParaRPr lang="en-US" sz="800" dirty="0"/>
           </a:p>
@@ -11925,7 +11717,7 @@
                 <a:ea typeface="Arial" pitchFamily="34" charset="-122"/>
                 <a:cs typeface="Arial" pitchFamily="34" charset="-120"/>
               </a:rPr>
-              <a:t>Software</a:t>
+              <a:t>Logiciels</a:t>
             </a:r>
             <a:endParaRPr lang="en-US" sz="900" dirty="0"/>
           </a:p>
@@ -12106,7 +11898,7 @@
                 <a:ea typeface="Arial" pitchFamily="34" charset="-122"/>
                 <a:cs typeface="Arial" pitchFamily="34" charset="-120"/>
               </a:rPr>
-              <a:t>Approval in progress</a:t>
+              <a:t>Approbation en cours</a:t>
             </a:r>
             <a:endParaRPr lang="en-US" sz="800" dirty="0"/>
           </a:p>
@@ -12165,7 +11957,7 @@
                 <a:ea typeface="Arial" pitchFamily="34" charset="-122"/>
                 <a:cs typeface="Arial" pitchFamily="34" charset="-120"/>
               </a:rPr>
-              <a:t>Weighbridge</a:t>
+              <a:t>Pont-bascule</a:t>
             </a:r>
             <a:endParaRPr lang="en-US" sz="900" dirty="0"/>
           </a:p>
@@ -12346,7 +12138,7 @@
                 <a:ea typeface="Arial" pitchFamily="34" charset="-122"/>
                 <a:cs typeface="Arial" pitchFamily="34" charset="-120"/>
               </a:rPr>
-              <a:t>Supplier selected, PO pending</a:t>
+              <a:t>Fournisseur choisi, BC en attente</a:t>
             </a:r>
             <a:endParaRPr lang="en-US" sz="800" dirty="0"/>
           </a:p>
@@ -12405,7 +12197,7 @@
                 <a:ea typeface="Arial" pitchFamily="34" charset="-122"/>
                 <a:cs typeface="Arial" pitchFamily="34" charset="-120"/>
               </a:rPr>
-              <a:t>Water System</a:t>
+              <a:t>Système d'eau</a:t>
             </a:r>
             <a:endParaRPr lang="en-US" sz="900" dirty="0"/>
           </a:p>
@@ -12444,7 +12236,7 @@
                 <a:ea typeface="Arial" pitchFamily="34" charset="-122"/>
                 <a:cs typeface="Arial" pitchFamily="34" charset="-120"/>
               </a:rPr>
-              <a:t>10,000 kg/h</a:t>
+              <a:t>10 000 kg/h</a:t>
             </a:r>
             <a:endParaRPr lang="en-US" sz="900" dirty="0"/>
           </a:p>
@@ -12586,7 +12378,7 @@
                 <a:ea typeface="Arial" pitchFamily="34" charset="-122"/>
                 <a:cs typeface="Arial" pitchFamily="34" charset="-120"/>
               </a:rPr>
-              <a:t>Pump/tank selection started</a:t>
+              <a:t>Sélection pompe/réservoir démarrée</a:t>
             </a:r>
             <a:endParaRPr lang="en-US" sz="800" dirty="0"/>
           </a:p>
@@ -12645,7 +12437,7 @@
                 <a:ea typeface="Arial" pitchFamily="34" charset="-122"/>
                 <a:cs typeface="Arial" pitchFamily="34" charset="-120"/>
               </a:rPr>
-              <a:t>Gas Installation</a:t>
+              <a:t>Installation gaz</a:t>
             </a:r>
             <a:endParaRPr lang="en-US" sz="900" dirty="0"/>
           </a:p>
@@ -12826,7 +12618,7 @@
                 <a:ea typeface="Arial" pitchFamily="34" charset="-122"/>
                 <a:cs typeface="Arial" pitchFamily="34" charset="-120"/>
               </a:rPr>
-              <a:t>Vendor due Jul 21</a:t>
+              <a:t>Fournisseur attendu le 21 juil.</a:t>
             </a:r>
             <a:endParaRPr lang="en-US" sz="800" dirty="0"/>
           </a:p>
@@ -12885,7 +12677,7 @@
                 <a:ea typeface="Arial" pitchFamily="34" charset="-122"/>
                 <a:cs typeface="Arial" pitchFamily="34" charset="-120"/>
               </a:rPr>
-              <a:t>Boiler System</a:t>
+              <a:t>Chaudière</a:t>
             </a:r>
             <a:endParaRPr lang="en-US" sz="900" dirty="0"/>
           </a:p>
@@ -12924,7 +12716,7 @@
                 <a:ea typeface="Arial" pitchFamily="34" charset="-122"/>
                 <a:cs typeface="Arial" pitchFamily="34" charset="-120"/>
               </a:rPr>
-              <a:t>6,000 kg/h steam</a:t>
+              <a:t>6 000 kg/h vapeur</a:t>
             </a:r>
             <a:endParaRPr lang="en-US" sz="900" dirty="0"/>
           </a:p>
@@ -13066,7 +12858,7 @@
                 <a:ea typeface="Arial" pitchFamily="34" charset="-122"/>
                 <a:cs typeface="Arial" pitchFamily="34" charset="-120"/>
               </a:rPr>
-              <a:t>Vendor finalization Jul 11</a:t>
+              <a:t>Finalisation fournisseur le 11 juil.</a:t>
             </a:r>
             <a:endParaRPr lang="en-US" sz="800" dirty="0"/>
           </a:p>
@@ -13125,7 +12917,7 @@
                 <a:ea typeface="Arial" pitchFamily="34" charset="-122"/>
                 <a:cs typeface="Arial" pitchFamily="34" charset="-120"/>
               </a:rPr>
-              <a:t>Compressor</a:t>
+              <a:t>Compresseur</a:t>
             </a:r>
             <a:endParaRPr lang="en-US" sz="900" dirty="0"/>
           </a:p>
@@ -13306,7 +13098,7 @@
                 <a:ea typeface="Arial" pitchFamily="34" charset="-122"/>
                 <a:cs typeface="Arial" pitchFamily="34" charset="-120"/>
               </a:rPr>
-              <a:t>Engineering done, vendor pending</a:t>
+              <a:t>Ingénierie faite, fournisseur en attente</a:t>
             </a:r>
             <a:endParaRPr lang="en-US" sz="800" dirty="0"/>
           </a:p>
@@ -13365,7 +13157,7 @@
                 <a:ea typeface="Arial" pitchFamily="34" charset="-122"/>
                 <a:cs typeface="Arial" pitchFamily="34" charset="-120"/>
               </a:rPr>
-              <a:t>Elevator</a:t>
+              <a:t>Ascenseur</a:t>
             </a:r>
             <a:endParaRPr lang="en-US" sz="900" dirty="0"/>
           </a:p>
@@ -13546,7 +13338,7 @@
                 <a:ea typeface="Arial" pitchFamily="34" charset="-122"/>
                 <a:cs typeface="Arial" pitchFamily="34" charset="-120"/>
               </a:rPr>
-              <a:t>Design validated</a:t>
+              <a:t>Conception validée</a:t>
             </a:r>
             <a:endParaRPr lang="en-US" sz="800" dirty="0"/>
           </a:p>
@@ -13605,7 +13397,7 @@
                 <a:ea typeface="Arial" pitchFamily="34" charset="-122"/>
                 <a:cs typeface="Arial" pitchFamily="34" charset="-120"/>
               </a:rPr>
-              <a:t>Oil Storage Tank</a:t>
+              <a:t>Cuve de stockage huile</a:t>
             </a:r>
             <a:endParaRPr lang="en-US" sz="900" dirty="0"/>
           </a:p>
@@ -13644,7 +13436,7 @@
                 <a:ea typeface="Arial" pitchFamily="34" charset="-122"/>
                 <a:cs typeface="Arial" pitchFamily="34" charset="-120"/>
               </a:rPr>
-              <a:t>2 x 20,000 L</a:t>
+              <a:t>2 x 20 000 L</a:t>
             </a:r>
             <a:endParaRPr lang="en-US" sz="900" dirty="0"/>
           </a:p>
@@ -13786,7 +13578,7 @@
                 <a:ea typeface="Arial" pitchFamily="34" charset="-122"/>
                 <a:cs typeface="Arial" pitchFamily="34" charset="-120"/>
               </a:rPr>
-              <a:t>CRITICAL: +8 weeks delayed</a:t>
+              <a:t>CRITIQUE : +8 sem. de retard</a:t>
             </a:r>
             <a:endParaRPr lang="en-US" sz="800" dirty="0"/>
           </a:p>
@@ -13845,7 +13637,7 @@
                 <a:ea typeface="Arial" pitchFamily="34" charset="-122"/>
                 <a:cs typeface="Arial" pitchFamily="34" charset="-120"/>
               </a:rPr>
-              <a:t>Solar Electricity</a:t>
+              <a:t>Solaire</a:t>
             </a:r>
             <a:endParaRPr lang="en-US" sz="900" dirty="0"/>
           </a:p>
@@ -13884,7 +13676,7 @@
                 <a:ea typeface="Arial" pitchFamily="34" charset="-122"/>
                 <a:cs typeface="Arial" pitchFamily="34" charset="-120"/>
               </a:rPr>
-              <a:t>480 KVA target</a:t>
+              <a:t>480 KVA cible</a:t>
             </a:r>
             <a:endParaRPr lang="en-US" sz="900" dirty="0"/>
           </a:p>
@@ -14004,7 +13796,7 @@
                 <a:ea typeface="Arial" pitchFamily="34" charset="-122"/>
                 <a:cs typeface="Arial" pitchFamily="34" charset="-120"/>
               </a:rPr>
-              <a:t>Not yet initiated</a:t>
+              <a:t>Non encore lancé</a:t>
             </a:r>
             <a:endParaRPr lang="en-US" sz="800" dirty="0"/>
           </a:p>
@@ -14043,7 +13835,7 @@
                 <a:ea typeface="Arial" pitchFamily="34" charset="-122"/>
                 <a:cs typeface="Arial" pitchFamily="34" charset="-120"/>
               </a:rPr>
-              <a:t>PetFactory Maroc  |  Investor Update  |  August 2026</a:t>
+              <a:t>PetFactory Maroc  |  Mise à jour Investisseurs  |  Août 2026</a:t>
             </a:r>
             <a:endParaRPr lang="en-US" sz="800" dirty="0"/>
           </a:p>
@@ -14114,7 +13906,7 @@
                 <a:ea typeface="Calibri" pitchFamily="34" charset="-122"/>
                 <a:cs typeface="Calibri" pitchFamily="34" charset="-120"/>
               </a:rPr>
-              <a:t>Key Systems Deep Dive</a:t>
+              <a:t>Systèmes Clés en Détail</a:t>
             </a:r>
             <a:endParaRPr lang="en-US" sz="3200" dirty="0"/>
           </a:p>
@@ -14202,7 +13994,7 @@
                 <a:ea typeface="Calibri" pitchFamily="34" charset="-122"/>
                 <a:cs typeface="Calibri" pitchFamily="34" charset="-120"/>
               </a:rPr>
-              <a:t>Boiler System</a:t>
+              <a:t>Chaudière</a:t>
             </a:r>
             <a:endParaRPr lang="en-US" sz="1600" dirty="0"/>
           </a:p>
@@ -14241,7 +14033,7 @@
                 <a:ea typeface="Arial" pitchFamily="34" charset="-122"/>
                 <a:cs typeface="Arial" pitchFamily="34" charset="-120"/>
               </a:rPr>
-              <a:t>2 fire-tube steam boilers (N+1 logic)</a:t>
+              <a:t>2 chaudières vapeur à tubes de fumée (N+1)</a:t>
             </a:r>
             <a:endParaRPr lang="en-US" sz="900" dirty="0"/>
           </a:p>
@@ -14280,7 +14072,7 @@
                 <a:ea typeface="Arial" pitchFamily="34" charset="-122"/>
                 <a:cs typeface="Arial" pitchFamily="34" charset="-120"/>
               </a:rPr>
-              <a:t>Three-pass wet-back design</a:t>
+              <a:t>Conception trois passes à fond humide</a:t>
             </a:r>
             <a:endParaRPr lang="en-US" sz="900" dirty="0"/>
           </a:p>
@@ -14319,7 +14111,7 @@
                 <a:ea typeface="Arial" pitchFamily="34" charset="-122"/>
                 <a:cs typeface="Arial" pitchFamily="34" charset="-120"/>
               </a:rPr>
-              <a:t>Peak demand: 2,600 kg/h saturated steam</a:t>
+              <a:t>Demande pic : 2 600 kg/h vapeur saturée</a:t>
             </a:r>
             <a:endParaRPr lang="en-US" sz="900" dirty="0"/>
           </a:p>
@@ -14358,7 +14150,7 @@
                 <a:ea typeface="Arial" pitchFamily="34" charset="-122"/>
                 <a:cs typeface="Arial" pitchFamily="34" charset="-120"/>
               </a:rPr>
-              <a:t>Unit size: 1,600-2,000 kg/h each</a:t>
+              <a:t>Capacité unitaire : 1 600-2 000 kg/h</a:t>
             </a:r>
             <a:endParaRPr lang="en-US" sz="900" dirty="0"/>
           </a:p>
@@ -14397,7 +14189,7 @@
                 <a:ea typeface="Arial" pitchFamily="34" charset="-122"/>
                 <a:cs typeface="Arial" pitchFamily="34" charset="-120"/>
               </a:rPr>
-              <a:t>Design: 10 barg / Operating: 7-8 barg</a:t>
+              <a:t>Conception : 10 barg / Exploitation : 7-8 barg</a:t>
             </a:r>
             <a:endParaRPr lang="en-US" sz="900" dirty="0"/>
           </a:p>
@@ -14436,7 +14228,7 @@
                 <a:ea typeface="Arial" pitchFamily="34" charset="-122"/>
                 <a:cs typeface="Arial" pitchFamily="34" charset="-120"/>
               </a:rPr>
-              <a:t>Dual-fuel: LPG primary, NG ready</a:t>
+              <a:t>Bicombustible : GPL principal, GN prêt</a:t>
             </a:r>
             <a:endParaRPr lang="en-US" sz="900" dirty="0"/>
           </a:p>
@@ -14475,7 +14267,7 @@
                 <a:ea typeface="Arial" pitchFamily="34" charset="-122"/>
                 <a:cs typeface="Arial" pitchFamily="34" charset="-120"/>
               </a:rPr>
-              <a:t>Efficiency: ≥94% NG / ≥93% LPG</a:t>
+              <a:t>Rendement : ≥94% GN / ≥93% GPL</a:t>
             </a:r>
             <a:endParaRPr lang="en-US" sz="900" dirty="0"/>
           </a:p>
@@ -14514,7 +14306,7 @@
                 <a:ea typeface="Arial" pitchFamily="34" charset="-122"/>
                 <a:cs typeface="Arial" pitchFamily="34" charset="-120"/>
               </a:rPr>
-              <a:t>Incl. feedwater, deaerator, softener, RO</a:t>
+              <a:t>Incl. alimentation eau, dégazeur, adoucisseur, OI</a:t>
             </a:r>
             <a:endParaRPr lang="en-US" sz="900" dirty="0"/>
           </a:p>
@@ -14553,7 +14345,7 @@
                 <a:ea typeface="Arial" pitchFamily="34" charset="-122"/>
                 <a:cs typeface="Arial" pitchFamily="34" charset="-120"/>
               </a:rPr>
-              <a:t>Culinary steam train (316L SS, ≤2μm)</a:t>
+              <a:t>Train vapeur culinaire (316L SS, ≤2μm)</a:t>
             </a:r>
             <a:endParaRPr lang="en-US" sz="900" dirty="0"/>
           </a:p>
@@ -14641,7 +14433,7 @@
                 <a:ea typeface="Calibri" pitchFamily="34" charset="-122"/>
                 <a:cs typeface="Calibri" pitchFamily="34" charset="-120"/>
               </a:rPr>
-              <a:t>Electrical &amp; Power</a:t>
+              <a:t>Électricité &amp; Énergie</a:t>
             </a:r>
             <a:endParaRPr lang="en-US" sz="1600" dirty="0"/>
           </a:p>
@@ -14680,7 +14472,7 @@
                 <a:ea typeface="Arial" pitchFamily="34" charset="-122"/>
                 <a:cs typeface="Arial" pitchFamily="34" charset="-120"/>
               </a:rPr>
-              <a:t>1,600 KVA transformer (PO signed)</a:t>
+              <a:t>Transformateur 1 600 KVA (BC signé)</a:t>
             </a:r>
             <a:endParaRPr lang="en-US" sz="900" dirty="0"/>
           </a:p>
@@ -14719,7 +14511,7 @@
                 <a:ea typeface="Arial" pitchFamily="34" charset="-122"/>
                 <a:cs typeface="Arial" pitchFamily="34" charset="-120"/>
               </a:rPr>
-              <a:t>Manufacturing starts: July 1, 2026</a:t>
+              <a:t>Fabrication démarre : 1er juillet 2026</a:t>
             </a:r>
             <a:endParaRPr lang="en-US" sz="900" dirty="0"/>
           </a:p>
@@ -14758,7 +14550,7 @@
                 <a:ea typeface="Arial" pitchFamily="34" charset="-122"/>
                 <a:cs typeface="Arial" pitchFamily="34" charset="-120"/>
               </a:rPr>
-              <a:t>12-week lead time to delivery</a:t>
+              <a:t>Délai de livraison : 12 semaines</a:t>
             </a:r>
             <a:endParaRPr lang="en-US" sz="900" dirty="0"/>
           </a:p>
@@ -14797,7 +14589,7 @@
                 <a:ea typeface="Arial" pitchFamily="34" charset="-122"/>
                 <a:cs typeface="Arial" pitchFamily="34" charset="-120"/>
               </a:rPr>
-              <a:t>Only system with signed purchase order</a:t>
+              <a:t>Seul système avec bon de commande signé</a:t>
             </a:r>
             <a:endParaRPr lang="en-US" sz="900" dirty="0"/>
           </a:p>
@@ -14836,7 +14628,7 @@
                 <a:ea typeface="Arial" pitchFamily="34" charset="-122"/>
                 <a:cs typeface="Arial" pitchFamily="34" charset="-120"/>
               </a:rPr>
-              <a:t>Solar target: 480 KVA (30% of load)</a:t>
+              <a:t>Cible solaire : 480 KVA (30% de la charge)</a:t>
             </a:r>
             <a:endParaRPr lang="en-US" sz="900" dirty="0"/>
           </a:p>
@@ -14875,7 +14667,7 @@
                 <a:ea typeface="Arial" pitchFamily="34" charset="-122"/>
                 <a:cs typeface="Arial" pitchFamily="34" charset="-120"/>
               </a:rPr>
-              <a:t>Framework: Moroccan Law 40-19</a:t>
+              <a:t>Cadre : Loi marocaine 40-19</a:t>
             </a:r>
             <a:endParaRPr lang="en-US" sz="900" dirty="0"/>
           </a:p>
@@ -14914,7 +14706,7 @@
                 <a:ea typeface="Arial" pitchFamily="34" charset="-122"/>
                 <a:cs typeface="Arial" pitchFamily="34" charset="-120"/>
               </a:rPr>
-              <a:t>Incentives: ECOTAQA / TATWIR</a:t>
+              <a:t>Incentives : ECOTAQA / TATWIR</a:t>
             </a:r>
             <a:endParaRPr lang="en-US" sz="900" dirty="0"/>
           </a:p>
@@ -14953,7 +14745,7 @@
                 <a:ea typeface="Arial" pitchFamily="34" charset="-122"/>
                 <a:cs typeface="Arial" pitchFamily="34" charset="-120"/>
               </a:rPr>
-              <a:t>Solar vendor: not yet initiated</a:t>
+              <a:t>Fournisseur solaire : non encore lancé</a:t>
             </a:r>
             <a:endParaRPr lang="en-US" sz="900" dirty="0"/>
           </a:p>
@@ -15041,7 +14833,7 @@
                 <a:ea typeface="Calibri" pitchFamily="34" charset="-122"/>
                 <a:cs typeface="Calibri" pitchFamily="34" charset="-120"/>
               </a:rPr>
-              <a:t>Air &amp; Water</a:t>
+              <a:t>Air &amp; Eau</a:t>
             </a:r>
             <a:endParaRPr lang="en-US" sz="1600" dirty="0"/>
           </a:p>
@@ -15080,7 +14872,7 @@
                 <a:ea typeface="Arial" pitchFamily="34" charset="-122"/>
                 <a:cs typeface="Arial" pitchFamily="34" charset="-120"/>
               </a:rPr>
-              <a:t>Compressed Air:</a:t>
+              <a:t>Air comprimé :</a:t>
             </a:r>
             <a:endParaRPr lang="en-US" sz="900" dirty="0"/>
           </a:p>
@@ -15119,7 +14911,7 @@
                 <a:ea typeface="Arial" pitchFamily="34" charset="-122"/>
                 <a:cs typeface="Arial" pitchFamily="34" charset="-120"/>
               </a:rPr>
-              <a:t>  2 x 37 kW compressors</a:t>
+              <a:t>  2 x 37 kW compresseurs</a:t>
             </a:r>
             <a:endParaRPr lang="en-US" sz="900" dirty="0"/>
           </a:p>
@@ -15158,7 +14950,7 @@
                 <a:ea typeface="Arial" pitchFamily="34" charset="-122"/>
                 <a:cs typeface="Arial" pitchFamily="34" charset="-120"/>
               </a:rPr>
-              <a:t>  Total demand: 363 m³/h</a:t>
+              <a:t>  Demande totale : 363 m³/h</a:t>
             </a:r>
             <a:endParaRPr lang="en-US" sz="900" dirty="0"/>
           </a:p>
@@ -15197,7 +14989,7 @@
                 <a:ea typeface="Arial" pitchFamily="34" charset="-122"/>
                 <a:cs typeface="Arial" pitchFamily="34" charset="-120"/>
               </a:rPr>
-              <a:t>  Product line: 258 m³/h</a:t>
+              <a:t>  Ligne produit : 258 m³/h</a:t>
             </a:r>
             <a:endParaRPr lang="en-US" sz="900" dirty="0"/>
           </a:p>
@@ -15236,7 +15028,7 @@
                 <a:ea typeface="Arial" pitchFamily="34" charset="-122"/>
                 <a:cs typeface="Arial" pitchFamily="34" charset="-120"/>
               </a:rPr>
-              <a:t>  Engineering complete</a:t>
+              <a:t>  Ingénierie terminée</a:t>
             </a:r>
             <a:endParaRPr lang="en-US" sz="900" dirty="0"/>
           </a:p>
@@ -15275,7 +15067,7 @@
                 <a:ea typeface="Arial" pitchFamily="34" charset="-122"/>
                 <a:cs typeface="Arial" pitchFamily="34" charset="-120"/>
               </a:rPr>
-              <a:t>Water System:</a:t>
+              <a:t>Système d'eau :</a:t>
             </a:r>
             <a:endParaRPr lang="en-US" sz="900" dirty="0"/>
           </a:p>
@@ -15314,7 +15106,7 @@
                 <a:ea typeface="Arial" pitchFamily="34" charset="-122"/>
                 <a:cs typeface="Arial" pitchFamily="34" charset="-120"/>
               </a:rPr>
-              <a:t>  Design capacity: 10,000 kg/h</a:t>
+              <a:t>  Capacité de conception : 10 000 kg/h</a:t>
             </a:r>
             <a:endParaRPr lang="en-US" sz="900" dirty="0"/>
           </a:p>
@@ -15353,7 +15145,7 @@
                 <a:ea typeface="Arial" pitchFamily="34" charset="-122"/>
                 <a:cs typeface="Arial" pitchFamily="34" charset="-120"/>
               </a:rPr>
-              <a:t>  Actual flow: 2,760 kg/h</a:t>
+              <a:t>  Débit réel : 2 760 kg/h</a:t>
             </a:r>
             <a:endParaRPr lang="en-US" sz="900" dirty="0"/>
           </a:p>
@@ -15392,7 +15184,7 @@
                 <a:ea typeface="Arial" pitchFamily="34" charset="-122"/>
                 <a:cs typeface="Arial" pitchFamily="34" charset="-120"/>
               </a:rPr>
-              <a:t>  Pump/tank selection in progress</a:t>
+              <a:t>  Sélection pompe/réservoir en cours</a:t>
             </a:r>
             <a:endParaRPr lang="en-US" sz="900" dirty="0"/>
           </a:p>
@@ -15429,7 +15221,7 @@
         <p:spPr>
           <a:xfrm>
             <a:off x="1005840" y="5349240"/>
-            <a:ext cx="2743200" cy="274320"/>
+            <a:ext cx="3200400" cy="274320"/>
           </a:xfrm>
           <a:prstGeom prst="rect">
             <a:avLst/>
@@ -15453,7 +15245,7 @@
                 <a:ea typeface="Calibri" pitchFamily="34" charset="-122"/>
                 <a:cs typeface="Calibri" pitchFamily="34" charset="-120"/>
               </a:rPr>
-              <a:t>Steam Distribution Summary</a:t>
+              <a:t>Synthèse Distribution Vapeur</a:t>
             </a:r>
             <a:endParaRPr lang="en-US" sz="1200" dirty="0"/>
           </a:p>
@@ -15492,7 +15284,7 @@
                 <a:ea typeface="Arial" pitchFamily="34" charset="-122"/>
                 <a:cs typeface="Arial" pitchFamily="34" charset="-120"/>
               </a:rPr>
-              <a:t>Dryer: 1.40 T/h (DN100)   |   Preconditioner: 0.75 T/h (DN60)   |   Fat Tanks: 0.30 T/h (DN32)   |   Total: 2.45 T/h   |   Condensate return: 69.7% (target 80%+ with flash recovery)</a:t>
+              <a:t>Séchoir : 1,40 T/h (DN100)   |   Préconditionneur : 0,75 T/h (DN60)   |   Cuves graisse : 0,30 T/h (DN32)   |   Total : 2,45 T/h   |   Retour condensats : 69,7% (cible 80%+ avec récupération flash)</a:t>
             </a:r>
             <a:endParaRPr lang="en-US" sz="1000" dirty="0"/>
           </a:p>
@@ -15531,7 +15323,7 @@
                 <a:ea typeface="Arial" pitchFamily="34" charset="-122"/>
                 <a:cs typeface="Arial" pitchFamily="34" charset="-120"/>
               </a:rPr>
-              <a:t>PetFactory Maroc  |  Investor Update  |  August 2026</a:t>
+              <a:t>PetFactory Maroc  |  Mise à jour Investisseurs  |  Août 2026</a:t>
             </a:r>
             <a:endParaRPr lang="en-US" sz="800" dirty="0"/>
           </a:p>
@@ -15602,7 +15394,7 @@
                 <a:ea typeface="Calibri" pitchFamily="34" charset="-122"/>
                 <a:cs typeface="Calibri" pitchFamily="34" charset="-120"/>
               </a:rPr>
-              <a:t>Project Timeline</a:t>
+              <a:t>Calendrier du Projet</a:t>
             </a:r>
             <a:endParaRPr lang="en-US" sz="3200" dirty="0"/>
           </a:p>
@@ -15641,7 +15433,7 @@
                 <a:ea typeface="Arial" pitchFamily="34" charset="-122"/>
                 <a:cs typeface="Arial" pitchFamily="34" charset="-120"/>
               </a:rPr>
-              <a:t>Target Commissioning: November 24, 2026</a:t>
+              <a:t>Mise en service cible : 24 novembre 2026</a:t>
             </a:r>
             <a:endParaRPr lang="en-US" sz="1400" dirty="0"/>
           </a:p>
@@ -15720,7 +15512,7 @@
                 <a:ea typeface="Arial" pitchFamily="34" charset="-122"/>
                 <a:cs typeface="Arial" pitchFamily="34" charset="-120"/>
               </a:rPr>
-              <a:t>May 31</a:t>
+              <a:t>31 mai</a:t>
             </a:r>
             <a:endParaRPr lang="en-US" sz="1000" dirty="0"/>
           </a:p>
@@ -15759,24 +15551,24 @@
                 <a:ea typeface="Arial" pitchFamily="34" charset="-122"/>
                 <a:cs typeface="Arial" pitchFamily="34" charset="-120"/>
               </a:rPr>
+              <a:t>Revue plans</a:t>
+            </a:r>
+            <a:endParaRPr lang="en-US" sz="900" dirty="0"/>
+          </a:p>
+          <a:p>
+            <a:pPr algn="ctr" indent="0" marL="0">
+              <a:buNone/>
+            </a:pPr>
+            <a:r>
+              <a:rPr lang="en-US" sz="900" dirty="0">
+                <a:solidFill>
+                  <a:srgbClr val="AABBCC"/>
+                </a:solidFill>
+                <a:latin typeface="Arial" pitchFamily="34" charset="0"/>
+                <a:ea typeface="Arial" pitchFamily="34" charset="-122"/>
+                <a:cs typeface="Arial" pitchFamily="34" charset="-120"/>
+              </a:rPr>
               <a:t>FAMSUN</a:t>
-            </a:r>
-            <a:endParaRPr lang="en-US" sz="900" dirty="0"/>
-          </a:p>
-          <a:p>
-            <a:pPr algn="ctr" indent="0" marL="0">
-              <a:buNone/>
-            </a:pPr>
-            <a:r>
-              <a:rPr lang="en-US" sz="900" dirty="0">
-                <a:solidFill>
-                  <a:srgbClr val="AABBCC"/>
-                </a:solidFill>
-                <a:latin typeface="Arial" pitchFamily="34" charset="0"/>
-                <a:ea typeface="Arial" pitchFamily="34" charset="-122"/>
-                <a:cs typeface="Arial" pitchFamily="34" charset="-120"/>
-              </a:rPr>
-              <a:t>Drawing Review</a:t>
             </a:r>
             <a:endParaRPr lang="en-US" sz="900" dirty="0"/>
           </a:p>
@@ -15874,7 +15666,7 @@
                 <a:ea typeface="Arial" pitchFamily="34" charset="-122"/>
                 <a:cs typeface="Arial" pitchFamily="34" charset="-120"/>
               </a:rPr>
-              <a:t>Jul 1</a:t>
+              <a:t>1er juil.</a:t>
             </a:r>
             <a:endParaRPr lang="en-US" sz="1000" dirty="0"/>
           </a:p>
@@ -15913,7 +15705,7 @@
                 <a:ea typeface="Arial" pitchFamily="34" charset="-122"/>
                 <a:cs typeface="Arial" pitchFamily="34" charset="-120"/>
               </a:rPr>
-              <a:t>Transformer</a:t>
+              <a:t>Début fab.</a:t>
             </a:r>
             <a:endParaRPr lang="en-US" sz="900" dirty="0"/>
           </a:p>
@@ -15930,7 +15722,7 @@
                 <a:ea typeface="Arial" pitchFamily="34" charset="-122"/>
                 <a:cs typeface="Arial" pitchFamily="34" charset="-120"/>
               </a:rPr>
-              <a:t>Mfg Starts</a:t>
+              <a:t>Transformateur</a:t>
             </a:r>
             <a:endParaRPr lang="en-US" sz="900" dirty="0"/>
           </a:p>
@@ -15989,7 +15781,7 @@
                 <a:ea typeface="Arial" pitchFamily="34" charset="-122"/>
                 <a:cs typeface="Arial" pitchFamily="34" charset="-120"/>
               </a:rPr>
-              <a:t>Jul 11</a:t>
+              <a:t>11 juil.</a:t>
             </a:r>
             <a:endParaRPr lang="en-US" sz="1000" dirty="0"/>
           </a:p>
@@ -16028,7 +15820,7 @@
                 <a:ea typeface="Arial" pitchFamily="34" charset="-122"/>
                 <a:cs typeface="Arial" pitchFamily="34" charset="-120"/>
               </a:rPr>
-              <a:t>Vendor</a:t>
+              <a:t>Finalisation</a:t>
             </a:r>
             <a:endParaRPr lang="en-US" sz="900" dirty="0"/>
           </a:p>
@@ -16045,7 +15837,7 @@
                 <a:ea typeface="Arial" pitchFamily="34" charset="-122"/>
                 <a:cs typeface="Arial" pitchFamily="34" charset="-120"/>
               </a:rPr>
-              <a:t>Finalization x3</a:t>
+              <a:t>Fournisseurs x3</a:t>
             </a:r>
             <a:endParaRPr lang="en-US" sz="900" dirty="0"/>
           </a:p>
@@ -16104,7 +15896,7 @@
                 <a:ea typeface="Arial" pitchFamily="34" charset="-122"/>
                 <a:cs typeface="Arial" pitchFamily="34" charset="-120"/>
               </a:rPr>
-              <a:t>Aug 18</a:t>
+              <a:t>18 août</a:t>
             </a:r>
             <a:endParaRPr lang="en-US" sz="1000" dirty="0"/>
           </a:p>
@@ -16143,7 +15935,7 @@
                 <a:ea typeface="Arial" pitchFamily="34" charset="-122"/>
                 <a:cs typeface="Arial" pitchFamily="34" charset="-120"/>
               </a:rPr>
-              <a:t>Equipment</a:t>
+              <a:t>Fabrication</a:t>
             </a:r>
             <a:endParaRPr lang="en-US" sz="900" dirty="0"/>
           </a:p>
@@ -16160,7 +15952,7 @@
                 <a:ea typeface="Arial" pitchFamily="34" charset="-122"/>
                 <a:cs typeface="Arial" pitchFamily="34" charset="-120"/>
               </a:rPr>
-              <a:t>Manufacturing</a:t>
+              <a:t>Équipements</a:t>
             </a:r>
             <a:endParaRPr lang="en-US" sz="900" dirty="0"/>
           </a:p>
@@ -16219,7 +16011,7 @@
                 <a:ea typeface="Arial" pitchFamily="34" charset="-122"/>
                 <a:cs typeface="Arial" pitchFamily="34" charset="-120"/>
               </a:rPr>
-              <a:t>Sep 18</a:t>
+              <a:t>18 sept.</a:t>
             </a:r>
             <a:endParaRPr lang="en-US" sz="1000" dirty="0"/>
           </a:p>
@@ -16258,7 +16050,7 @@
                 <a:ea typeface="Arial" pitchFamily="34" charset="-122"/>
                 <a:cs typeface="Arial" pitchFamily="34" charset="-120"/>
               </a:rPr>
-              <a:t>Equipment</a:t>
+              <a:t>Expédition</a:t>
             </a:r>
             <a:endParaRPr lang="en-US" sz="900" dirty="0"/>
           </a:p>
@@ -16275,7 +16067,7 @@
                 <a:ea typeface="Arial" pitchFamily="34" charset="-122"/>
                 <a:cs typeface="Arial" pitchFamily="34" charset="-120"/>
               </a:rPr>
-              <a:t>Shipping</a:t>
+              <a:t>Équipements</a:t>
             </a:r>
             <a:endParaRPr lang="en-US" sz="900" dirty="0"/>
           </a:p>
@@ -16334,7 +16126,7 @@
                 <a:ea typeface="Arial" pitchFamily="34" charset="-122"/>
                 <a:cs typeface="Arial" pitchFamily="34" charset="-120"/>
               </a:rPr>
-              <a:t>Oct 28</a:t>
+              <a:t>28 oct.</a:t>
             </a:r>
             <a:endParaRPr lang="en-US" sz="1000" dirty="0"/>
           </a:p>
@@ -16373,7 +16165,7 @@
                 <a:ea typeface="Arial" pitchFamily="34" charset="-122"/>
                 <a:cs typeface="Arial" pitchFamily="34" charset="-120"/>
               </a:rPr>
-              <a:t>Site</a:t>
+              <a:t>Livraisons</a:t>
             </a:r>
             <a:endParaRPr lang="en-US" sz="900" dirty="0"/>
           </a:p>
@@ -16390,7 +16182,7 @@
                 <a:ea typeface="Arial" pitchFamily="34" charset="-122"/>
                 <a:cs typeface="Arial" pitchFamily="34" charset="-120"/>
               </a:rPr>
-              <a:t>Deliveries</a:t>
+              <a:t>Sur site</a:t>
             </a:r>
             <a:endParaRPr lang="en-US" sz="900" dirty="0"/>
           </a:p>
@@ -16449,7 +16241,7 @@
                 <a:ea typeface="Arial" pitchFamily="34" charset="-122"/>
                 <a:cs typeface="Arial" pitchFamily="34" charset="-120"/>
               </a:rPr>
-              <a:t>Nov 8</a:t>
+              <a:t>8 nov.</a:t>
             </a:r>
             <a:endParaRPr lang="en-US" sz="1000" dirty="0"/>
           </a:p>
@@ -16505,7 +16297,7 @@
                 <a:ea typeface="Arial" pitchFamily="34" charset="-122"/>
                 <a:cs typeface="Arial" pitchFamily="34" charset="-120"/>
               </a:rPr>
-              <a:t>Complete</a:t>
+              <a:t>Terminée</a:t>
             </a:r>
             <a:endParaRPr lang="en-US" sz="900" dirty="0"/>
           </a:p>
@@ -16564,7 +16356,7 @@
                 <a:ea typeface="Arial" pitchFamily="34" charset="-122"/>
                 <a:cs typeface="Arial" pitchFamily="34" charset="-120"/>
               </a:rPr>
-              <a:t>Nov 24</a:t>
+              <a:t>24 nov.</a:t>
             </a:r>
             <a:endParaRPr lang="en-US" sz="1000" dirty="0"/>
           </a:p>
@@ -16603,7 +16395,7 @@
                 <a:ea typeface="Arial" pitchFamily="34" charset="-122"/>
                 <a:cs typeface="Arial" pitchFamily="34" charset="-120"/>
               </a:rPr>
-              <a:t>Commissioned</a:t>
+              <a:t>Mise en</a:t>
             </a:r>
             <a:endParaRPr lang="en-US" sz="900" dirty="0"/>
           </a:p>
@@ -16620,7 +16412,7 @@
                 <a:ea typeface="Arial" pitchFamily="34" charset="-122"/>
                 <a:cs typeface="Arial" pitchFamily="34" charset="-120"/>
               </a:rPr>
-              <a:t>&amp; Ready</a:t>
+              <a:t>Service</a:t>
             </a:r>
             <a:endParaRPr lang="en-US" sz="900" dirty="0"/>
           </a:p>
@@ -16681,7 +16473,7 @@
                 <a:ea typeface="Calibri" pitchFamily="34" charset="-122"/>
                 <a:cs typeface="Calibri" pitchFamily="34" charset="-120"/>
               </a:rPr>
-              <a:t>Critical Path Items</a:t>
+              <a:t>Chemin Critique</a:t>
             </a:r>
             <a:endParaRPr lang="en-US" sz="1600" dirty="0"/>
           </a:p>
@@ -16742,7 +16534,7 @@
                 <a:ea typeface="Arial" pitchFamily="34" charset="-122"/>
                 <a:cs typeface="Arial" pitchFamily="34" charset="-120"/>
               </a:rPr>
-              <a:t>NOW</a:t>
+              <a:t>MAINTENANT</a:t>
             </a:r>
             <a:endParaRPr lang="en-US" sz="800" dirty="0"/>
           </a:p>
@@ -16781,7 +16573,7 @@
                 <a:ea typeface="Arial" pitchFamily="34" charset="-122"/>
                 <a:cs typeface="Arial" pitchFamily="34" charset="-120"/>
               </a:rPr>
-              <a:t>Civil works start for boiler, compressor, weighbridge, elevator, water trenching</a:t>
+              <a:t>Travaux de génie civil pour chaudière, compresseur, pont-bascule, ascenseur, tranchées d'eau</a:t>
             </a:r>
             <a:endParaRPr lang="en-US" sz="1000" dirty="0"/>
           </a:p>
@@ -16820,7 +16612,7 @@
                 <a:ea typeface="Arial" pitchFamily="34" charset="-122"/>
                 <a:cs typeface="Arial" pitchFamily="34" charset="-120"/>
               </a:rPr>
-              <a:t>OVERDUE (was Jun 18)</a:t>
+              <a:t>EN RETARD (était 18 juin)</a:t>
             </a:r>
             <a:endParaRPr lang="en-US" sz="1000" dirty="0"/>
           </a:p>
@@ -16881,7 +16673,7 @@
                 <a:ea typeface="Arial" pitchFamily="34" charset="-122"/>
                 <a:cs typeface="Arial" pitchFamily="34" charset="-120"/>
               </a:rPr>
-              <a:t>2 WEEKS</a:t>
+              <a:t>2 SEMAINES</a:t>
             </a:r>
             <a:endParaRPr lang="en-US" sz="800" dirty="0"/>
           </a:p>
@@ -16920,7 +16712,7 @@
                 <a:ea typeface="Arial" pitchFamily="34" charset="-122"/>
                 <a:cs typeface="Arial" pitchFamily="34" charset="-120"/>
               </a:rPr>
-              <a:t>Vendor finalization: Boiler + Compressor + Elevator</a:t>
+              <a:t>Finalisation fournisseurs : Chaudière + Compresseur + Ascenseur</a:t>
             </a:r>
             <a:endParaRPr lang="en-US" sz="1000" dirty="0"/>
           </a:p>
@@ -16959,7 +16751,7 @@
                 <a:ea typeface="Arial" pitchFamily="34" charset="-122"/>
                 <a:cs typeface="Arial" pitchFamily="34" charset="-120"/>
               </a:rPr>
-              <a:t>Jul 11, 2026</a:t>
+              <a:t>11 juil. 2026</a:t>
             </a:r>
             <a:endParaRPr lang="en-US" sz="1000" dirty="0"/>
           </a:p>
@@ -17020,7 +16812,7 @@
                 <a:ea typeface="Arial" pitchFamily="34" charset="-122"/>
                 <a:cs typeface="Arial" pitchFamily="34" charset="-120"/>
               </a:rPr>
-              <a:t>3 WEEKS</a:t>
+              <a:t>3 SEMAINES</a:t>
             </a:r>
             <a:endParaRPr lang="en-US" sz="800" dirty="0"/>
           </a:p>
@@ -17059,7 +16851,7 @@
                 <a:ea typeface="Arial" pitchFamily="34" charset="-122"/>
                 <a:cs typeface="Arial" pitchFamily="34" charset="-120"/>
               </a:rPr>
-              <a:t>Gas installation vendor finalization</a:t>
+              <a:t>Finalisation fournisseur installation gaz</a:t>
             </a:r>
             <a:endParaRPr lang="en-US" sz="1000" dirty="0"/>
           </a:p>
@@ -17098,7 +16890,7 @@
                 <a:ea typeface="Arial" pitchFamily="34" charset="-122"/>
                 <a:cs typeface="Arial" pitchFamily="34" charset="-120"/>
               </a:rPr>
-              <a:t>Jul 21, 2026</a:t>
+              <a:t>21 juil. 2026</a:t>
             </a:r>
             <a:endParaRPr lang="en-US" sz="1000" dirty="0"/>
           </a:p>
@@ -17159,7 +16951,7 @@
                 <a:ea typeface="Arial" pitchFamily="34" charset="-122"/>
                 <a:cs typeface="Arial" pitchFamily="34" charset="-120"/>
               </a:rPr>
-              <a:t>6 WEEKS</a:t>
+              <a:t>6 SEMAINES</a:t>
             </a:r>
             <a:endParaRPr lang="en-US" sz="800" dirty="0"/>
           </a:p>
@@ -17198,7 +16990,7 @@
                 <a:ea typeface="Arial" pitchFamily="34" charset="-122"/>
                 <a:cs typeface="Arial" pitchFamily="34" charset="-120"/>
               </a:rPr>
-              <a:t>Equipment manufacturing complete (boiler, elevator)</a:t>
+              <a:t>Fabrication équipements terminée (chaudière, ascenseur)</a:t>
             </a:r>
             <a:endParaRPr lang="en-US" sz="1000" dirty="0"/>
           </a:p>
@@ -17237,7 +17029,7 @@
                 <a:ea typeface="Arial" pitchFamily="34" charset="-122"/>
                 <a:cs typeface="Arial" pitchFamily="34" charset="-120"/>
               </a:rPr>
-              <a:t>Aug 18, 2026</a:t>
+              <a:t>18 août 2026</a:t>
             </a:r>
             <a:endParaRPr lang="en-US" sz="1000" dirty="0"/>
           </a:p>
@@ -17298,7 +17090,7 @@
                 <a:ea typeface="Arial" pitchFamily="34" charset="-122"/>
                 <a:cs typeface="Arial" pitchFamily="34" charset="-120"/>
               </a:rPr>
-              <a:t>10 WEEKS</a:t>
+              <a:t>10 SEMAINES</a:t>
             </a:r>
             <a:endParaRPr lang="en-US" sz="800" dirty="0"/>
           </a:p>
@@ -17337,7 +17129,7 @@
                 <a:ea typeface="Arial" pitchFamily="34" charset="-122"/>
                 <a:cs typeface="Arial" pitchFamily="34" charset="-120"/>
               </a:rPr>
-              <a:t>Major equipment shipping complete</a:t>
+              <a:t>Expédition équipements majeurs terminée</a:t>
             </a:r>
             <a:endParaRPr lang="en-US" sz="1000" dirty="0"/>
           </a:p>
@@ -17376,7 +17168,7 @@
                 <a:ea typeface="Arial" pitchFamily="34" charset="-122"/>
                 <a:cs typeface="Arial" pitchFamily="34" charset="-120"/>
               </a:rPr>
-              <a:t>Sep 18, 2026</a:t>
+              <a:t>18 sept. 2026</a:t>
             </a:r>
             <a:endParaRPr lang="en-US" sz="1000" dirty="0"/>
           </a:p>
@@ -17437,7 +17229,7 @@
                 <a:ea typeface="Arial" pitchFamily="34" charset="-122"/>
                 <a:cs typeface="Arial" pitchFamily="34" charset="-120"/>
               </a:rPr>
-              <a:t>12 WEEKS</a:t>
+              <a:t>12 SEMAINES</a:t>
             </a:r>
             <a:endParaRPr lang="en-US" sz="800" dirty="0"/>
           </a:p>
@@ -17476,7 +17268,7 @@
                 <a:ea typeface="Arial" pitchFamily="34" charset="-122"/>
                 <a:cs typeface="Arial" pitchFamily="34" charset="-120"/>
               </a:rPr>
-              <a:t>Boiler delivery on site (hard constraint from RFP)</a:t>
+              <a:t>Livraison chaudière sur site (contrainte ferme du cahier des charges)</a:t>
             </a:r>
             <a:endParaRPr lang="en-US" sz="1000" dirty="0"/>
           </a:p>
@@ -17515,7 +17307,7 @@
                 <a:ea typeface="Arial" pitchFamily="34" charset="-122"/>
                 <a:cs typeface="Arial" pitchFamily="34" charset="-120"/>
               </a:rPr>
-              <a:t>Oct 19, 2026</a:t>
+              <a:t>19 oct. 2026</a:t>
             </a:r>
             <a:endParaRPr lang="en-US" sz="1000" dirty="0"/>
           </a:p>
@@ -17554,7 +17346,7 @@
                 <a:ea typeface="Arial" pitchFamily="34" charset="-122"/>
                 <a:cs typeface="Arial" pitchFamily="34" charset="-120"/>
               </a:rPr>
-              <a:t>PetFactory Maroc  |  Investor Update  |  August 2026</a:t>
+              <a:t>PetFactory Maroc  |  Mise à jour Investisseurs  |  Août 2026</a:t>
             </a:r>
             <a:endParaRPr lang="en-US" sz="800" dirty="0"/>
           </a:p>
@@ -17625,7 +17417,7 @@
                 <a:ea typeface="Calibri" pitchFamily="34" charset="-122"/>
                 <a:cs typeface="Calibri" pitchFamily="34" charset="-120"/>
               </a:rPr>
-              <a:t>Risks &amp; Mitigation</a:t>
+              <a:t>Risques &amp; Atténuation</a:t>
             </a:r>
             <a:endParaRPr lang="en-US" sz="3200" dirty="0"/>
           </a:p>
@@ -17715,7 +17507,7 @@
                 <a:ea typeface="Arial" pitchFamily="34" charset="-122"/>
                 <a:cs typeface="Arial" pitchFamily="34" charset="-120"/>
               </a:rPr>
-              <a:t>HIGH</a:t>
+              <a:t>ÉLEVÉ</a:t>
             </a:r>
             <a:endParaRPr lang="en-US" sz="800" dirty="0"/>
           </a:p>
@@ -17754,7 +17546,7 @@
                 <a:ea typeface="Calibri" pitchFamily="34" charset="-122"/>
                 <a:cs typeface="Calibri" pitchFamily="34" charset="-120"/>
               </a:rPr>
-              <a:t>Oil Storage Tank Delay</a:t>
+              <a:t>Retard Cuve de Stockage Huile</a:t>
             </a:r>
             <a:endParaRPr lang="en-US" sz="1300" dirty="0"/>
           </a:p>
@@ -17796,7 +17588,7 @@
                 <a:ea typeface="Arial" pitchFamily="34" charset="-122"/>
                 <a:cs typeface="Arial" pitchFamily="34" charset="-120"/>
               </a:rPr>
-              <a:t>Annex D spec review blocked since April 21 (+8 weeks). Only RED system. Vendor not selected, PO not issued, foundation not started, oversized transport permit not initiated.</a:t>
+              <a:t>Revue spécification Annexe D bloquée depuis le 21 avril (+8 sem.). Seul système ROUGE. Fournisseur non sélectionné, BC non émis, fondation non démarrée, permis transport hors gabarit non initié.</a:t>
             </a:r>
             <a:endParaRPr lang="en-US" sz="850" dirty="0"/>
           </a:p>
@@ -17811,7 +17603,7 @@
         <p:spPr>
           <a:xfrm>
             <a:off x="6400800" y="1261872"/>
-            <a:ext cx="914400" cy="274320"/>
+            <a:ext cx="1097280" cy="274320"/>
           </a:xfrm>
           <a:prstGeom prst="rect">
             <a:avLst/>
@@ -17835,7 +17627,7 @@
                 <a:ea typeface="Arial" pitchFamily="34" charset="-122"/>
                 <a:cs typeface="Arial" pitchFamily="34" charset="-120"/>
               </a:rPr>
-              <a:t>Mitigation:</a:t>
+              <a:t>Atténuation :</a:t>
             </a:r>
             <a:endParaRPr lang="en-US" sz="900" dirty="0"/>
           </a:p>
@@ -17877,7 +17669,7 @@
                 <a:ea typeface="Arial" pitchFamily="34" charset="-122"/>
                 <a:cs typeface="Arial" pitchFamily="34" charset="-120"/>
               </a:rPr>
-              <a:t>Immediate unblocking of spec review. Parallel-track vendor selection and permit application. Escalate to project leadership.</a:t>
+              <a:t>Déblocage immédiat de la revue. Sélection fournisseur et demande de permis en parallèle. Escalade à la direction du projet.</a:t>
             </a:r>
             <a:endParaRPr lang="en-US" sz="850" dirty="0"/>
           </a:p>
@@ -17967,7 +17759,7 @@
                 <a:ea typeface="Arial" pitchFamily="34" charset="-122"/>
                 <a:cs typeface="Arial" pitchFamily="34" charset="-120"/>
               </a:rPr>
-              <a:t>HIGH</a:t>
+              <a:t>ÉLEVÉ</a:t>
             </a:r>
             <a:endParaRPr lang="en-US" sz="800" dirty="0"/>
           </a:p>
@@ -18006,7 +17798,7 @@
                 <a:ea typeface="Calibri" pitchFamily="34" charset="-122"/>
                 <a:cs typeface="Calibri" pitchFamily="34" charset="-120"/>
               </a:rPr>
-              <a:t>Civil Works Not Started</a:t>
+              <a:t>Travaux de Génie Civil Non Démarrés</a:t>
             </a:r>
             <a:endParaRPr lang="en-US" sz="1300" dirty="0"/>
           </a:p>
@@ -18048,7 +17840,7 @@
                 <a:ea typeface="Arial" pitchFamily="34" charset="-122"/>
                 <a:cs typeface="Arial" pitchFamily="34" charset="-120"/>
               </a:rPr>
-              <a:t>5 foundation packages were due June 18 and are all unstarted (boiler, compressor, weighbridge, elevator shaft, water trenching).</a:t>
+              <a:t>5 lots de fondations étaient prévus le 18 juin et sont tous non démarrés (chaudière, compresseur, pont-bascule, cage ascenseur, tranchées d'eau).</a:t>
             </a:r>
             <a:endParaRPr lang="en-US" sz="850" dirty="0"/>
           </a:p>
@@ -18063,7 +17855,7 @@
         <p:spPr>
           <a:xfrm>
             <a:off x="6400800" y="2340864"/>
-            <a:ext cx="914400" cy="274320"/>
+            <a:ext cx="1097280" cy="274320"/>
           </a:xfrm>
           <a:prstGeom prst="rect">
             <a:avLst/>
@@ -18087,7 +17879,7 @@
                 <a:ea typeface="Arial" pitchFamily="34" charset="-122"/>
                 <a:cs typeface="Arial" pitchFamily="34" charset="-120"/>
               </a:rPr>
-              <a:t>Mitigation:</a:t>
+              <a:t>Atténuation :</a:t>
             </a:r>
             <a:endParaRPr lang="en-US" sz="900" dirty="0"/>
           </a:p>
@@ -18129,7 +17921,7 @@
                 <a:ea typeface="Arial" pitchFamily="34" charset="-122"/>
                 <a:cs typeface="Arial" pitchFamily="34" charset="-120"/>
               </a:rPr>
-              <a:t>Fast-track contractor mobilization. Prioritize boiler and compressor foundations on critical path. Weekly progress tracking.</a:t>
+              <a:t>Mobilisation accélérée des entrepreneurs. Prioriser les fondations chaudière et compresseur sur le chemin critique. Suivi hebdomadaire.</a:t>
             </a:r>
             <a:endParaRPr lang="en-US" sz="850" dirty="0"/>
           </a:p>
@@ -18219,7 +18011,7 @@
                 <a:ea typeface="Arial" pitchFamily="34" charset="-122"/>
                 <a:cs typeface="Arial" pitchFamily="34" charset="-120"/>
               </a:rPr>
-              <a:t>MEDIUM</a:t>
+              <a:t>MOYEN</a:t>
             </a:r>
             <a:endParaRPr lang="en-US" sz="800" dirty="0"/>
           </a:p>
@@ -18258,7 +18050,7 @@
                 <a:ea typeface="Calibri" pitchFamily="34" charset="-122"/>
                 <a:cs typeface="Calibri" pitchFamily="34" charset="-120"/>
               </a:rPr>
-              <a:t>Vendor Deadline Compression</a:t>
+              <a:t>Compression des Délais Fournisseurs</a:t>
             </a:r>
             <a:endParaRPr lang="en-US" sz="1300" dirty="0"/>
           </a:p>
@@ -18300,7 +18092,7 @@
                 <a:ea typeface="Arial" pitchFamily="34" charset="-122"/>
                 <a:cs typeface="Arial" pitchFamily="34" charset="-120"/>
               </a:rPr>
-              <a:t>Boiler, compressor, and elevator vendors must be finalized by July 11. Manufacturing must start July 18 to meet September shipping window.</a:t>
+              <a:t>Les fournisseurs chaudière, compresseur et ascenseur doivent être finalisés d'ici le 11 juillet. La fabrication doit démarrer le 18 juillet pour respecter la fenêtre d'expédition de septembre.</a:t>
             </a:r>
             <a:endParaRPr lang="en-US" sz="850" dirty="0"/>
           </a:p>
@@ -18315,7 +18107,7 @@
         <p:spPr>
           <a:xfrm>
             <a:off x="6400800" y="3419856"/>
-            <a:ext cx="914400" cy="274320"/>
+            <a:ext cx="1097280" cy="274320"/>
           </a:xfrm>
           <a:prstGeom prst="rect">
             <a:avLst/>
@@ -18339,7 +18131,7 @@
                 <a:ea typeface="Arial" pitchFamily="34" charset="-122"/>
                 <a:cs typeface="Arial" pitchFamily="34" charset="-120"/>
               </a:rPr>
-              <a:t>Mitigation:</a:t>
+              <a:t>Atténuation :</a:t>
             </a:r>
             <a:endParaRPr lang="en-US" sz="900" dirty="0"/>
           </a:p>
@@ -18381,7 +18173,7 @@
                 <a:ea typeface="Arial" pitchFamily="34" charset="-122"/>
                 <a:cs typeface="Arial" pitchFamily="34" charset="-120"/>
               </a:rPr>
-              <a:t>Daily follow-up with shortlisted vendors. Pre-negotiate LOI terms. Prepare backup vendor options.</a:t>
+              <a:t>Suivi quotidien avec fournisseurs présélectionnés. Pré-négocier les conditions LOI. Préparer des fournisseurs de secours.</a:t>
             </a:r>
             <a:endParaRPr lang="en-US" sz="850" dirty="0"/>
           </a:p>
@@ -18471,7 +18263,7 @@
                 <a:ea typeface="Arial" pitchFamily="34" charset="-122"/>
                 <a:cs typeface="Arial" pitchFamily="34" charset="-120"/>
               </a:rPr>
-              <a:t>MEDIUM</a:t>
+              <a:t>MOYEN</a:t>
             </a:r>
             <a:endParaRPr lang="en-US" sz="800" dirty="0"/>
           </a:p>
@@ -18510,7 +18302,7 @@
                 <a:ea typeface="Calibri" pitchFamily="34" charset="-122"/>
                 <a:cs typeface="Calibri" pitchFamily="34" charset="-120"/>
               </a:rPr>
-              <a:t>FAMSUN Silo Visibility</a:t>
+              <a:t>Visibilité Silos FAMSUN</a:t>
             </a:r>
             <a:endParaRPr lang="en-US" sz="1300" dirty="0"/>
           </a:p>
@@ -18552,7 +18344,7 @@
                 <a:ea typeface="Arial" pitchFamily="34" charset="-122"/>
                 <a:cs typeface="Arial" pitchFamily="34" charset="-120"/>
               </a:rPr>
-              <a:t>Silo scope entirely dependent on FAMSUN Chinese team. No independent tracking. Last update: April 2026.</a:t>
+              <a:t>Le périmètre silos dépend entièrement de l'équipe FAMSUN en Chine. Aucun suivi indépendant. Dernière mise à jour : avril 2026.</a:t>
             </a:r>
             <a:endParaRPr lang="en-US" sz="850" dirty="0"/>
           </a:p>
@@ -18567,7 +18359,7 @@
         <p:spPr>
           <a:xfrm>
             <a:off x="6400800" y="4498848"/>
-            <a:ext cx="914400" cy="274320"/>
+            <a:ext cx="1097280" cy="274320"/>
           </a:xfrm>
           <a:prstGeom prst="rect">
             <a:avLst/>
@@ -18591,7 +18383,7 @@
                 <a:ea typeface="Arial" pitchFamily="34" charset="-122"/>
                 <a:cs typeface="Arial" pitchFamily="34" charset="-120"/>
               </a:rPr>
-              <a:t>Mitigation:</a:t>
+              <a:t>Atténuation :</a:t>
             </a:r>
             <a:endParaRPr lang="en-US" sz="900" dirty="0"/>
           </a:p>
@@ -18633,7 +18425,7 @@
                 <a:ea typeface="Arial" pitchFamily="34" charset="-122"/>
                 <a:cs typeface="Arial" pitchFamily="34" charset="-120"/>
               </a:rPr>
-              <a:t>Request formal status update and delivery schedule from FAMSUN. Establish bi-weekly check-ins. Define acceptance criteria.</a:t>
+              <a:t>Demander une mise à jour formelle et un calendrier de livraison à FAMSUN. Points bimensuels. Définir les critères de réception.</a:t>
             </a:r>
             <a:endParaRPr lang="en-US" sz="850" dirty="0"/>
           </a:p>
@@ -18723,7 +18515,7 @@
                 <a:ea typeface="Arial" pitchFamily="34" charset="-122"/>
                 <a:cs typeface="Arial" pitchFamily="34" charset="-120"/>
               </a:rPr>
-              <a:t>LOW</a:t>
+              <a:t>FAIBLE</a:t>
             </a:r>
             <a:endParaRPr lang="en-US" sz="800" dirty="0"/>
           </a:p>
@@ -18762,7 +18554,7 @@
                 <a:ea typeface="Calibri" pitchFamily="34" charset="-122"/>
                 <a:cs typeface="Calibri" pitchFamily="34" charset="-120"/>
               </a:rPr>
-              <a:t>Solar Generation (0% Progress)</a:t>
+              <a:t>Solaire (0% d'avancement)</a:t>
             </a:r>
             <a:endParaRPr lang="en-US" sz="1300" dirty="0"/>
           </a:p>
@@ -18804,7 +18596,7 @@
                 <a:ea typeface="Arial" pitchFamily="34" charset="-122"/>
                 <a:cs typeface="Arial" pitchFamily="34" charset="-120"/>
               </a:rPr>
-              <a:t>No tasks started for 480 KVA solar target. Not yet on critical path but represents cost savings and ESG positioning.</a:t>
+              <a:t>Aucune tâche démarrée pour la cible solaire de 480 KVA. Pas encore sur le chemin critique mais représente des économies et un positionnement ESG.</a:t>
             </a:r>
             <a:endParaRPr lang="en-US" sz="850" dirty="0"/>
           </a:p>
@@ -18819,7 +18611,7 @@
         <p:spPr>
           <a:xfrm>
             <a:off x="6400800" y="5577840"/>
-            <a:ext cx="914400" cy="274320"/>
+            <a:ext cx="1097280" cy="274320"/>
           </a:xfrm>
           <a:prstGeom prst="rect">
             <a:avLst/>
@@ -18843,7 +18635,7 @@
                 <a:ea typeface="Arial" pitchFamily="34" charset="-122"/>
                 <a:cs typeface="Arial" pitchFamily="34" charset="-120"/>
               </a:rPr>
-              <a:t>Mitigation:</a:t>
+              <a:t>Atténuation :</a:t>
             </a:r>
             <a:endParaRPr lang="en-US" sz="900" dirty="0"/>
           </a:p>
@@ -18885,7 +18677,7 @@
                 <a:ea typeface="Arial" pitchFamily="34" charset="-122"/>
                 <a:cs typeface="Arial" pitchFamily="34" charset="-120"/>
               </a:rPr>
-              <a:t>Initiate vendor RFP in Q4 2026. Leverage Moroccan Law 40-19 incentives. Can be commissioned post-startup.</a:t>
+              <a:t>Lancer l'appel d'offres fournisseurs au T4 2026. Tirer parti des incitations de la Loi 40-19. Mise en service possible post-démarrage.</a:t>
             </a:r>
             <a:endParaRPr lang="en-US" sz="850" dirty="0"/>
           </a:p>
@@ -18924,7 +18716,7 @@
                 <a:ea typeface="Arial" pitchFamily="34" charset="-122"/>
                 <a:cs typeface="Arial" pitchFamily="34" charset="-120"/>
               </a:rPr>
-              <a:t>PetFactory Maroc  |  Investor Update  |  August 2026</a:t>
+              <a:t>PetFactory Maroc  |  Mise à jour Investisseurs  |  Août 2026</a:t>
             </a:r>
             <a:endParaRPr lang="en-US" sz="800" dirty="0"/>
           </a:p>
@@ -18995,7 +18787,7 @@
                 <a:ea typeface="Calibri" pitchFamily="34" charset="-122"/>
                 <a:cs typeface="Calibri" pitchFamily="34" charset="-120"/>
               </a:rPr>
-              <a:t>Compliance &amp; Quality Assurance</a:t>
+              <a:t>Conformité &amp; Assurance Qualité</a:t>
             </a:r>
             <a:endParaRPr lang="en-US" sz="3200" dirty="0"/>
           </a:p>
@@ -19056,7 +18848,7 @@
                 <a:ea typeface="Calibri" pitchFamily="34" charset="-122"/>
                 <a:cs typeface="Calibri" pitchFamily="34" charset="-120"/>
               </a:rPr>
-              <a:t>Certifications &amp; Standards</a:t>
+              <a:t>Certifications &amp; Normes</a:t>
             </a:r>
             <a:endParaRPr lang="en-US" sz="1800" dirty="0"/>
           </a:p>
@@ -19154,7 +18946,7 @@
                 <a:ea typeface="Arial" pitchFamily="34" charset="-122"/>
                 <a:cs typeface="Arial" pitchFamily="34" charset="-120"/>
               </a:rPr>
-              <a:t>In Implementation</a:t>
+              <a:t>En cours de mise en place</a:t>
             </a:r>
             <a:endParaRPr lang="en-US" sz="1000" dirty="0"/>
           </a:p>
@@ -19252,7 +19044,7 @@
                 <a:ea typeface="Arial" pitchFamily="34" charset="-122"/>
                 <a:cs typeface="Arial" pitchFamily="34" charset="-120"/>
               </a:rPr>
-              <a:t>In Implementation</a:t>
+              <a:t>En cours de mise en place</a:t>
             </a:r>
             <a:endParaRPr lang="en-US" sz="1000" dirty="0"/>
           </a:p>
@@ -19311,7 +19103,7 @@
                 <a:ea typeface="Arial" pitchFamily="34" charset="-122"/>
                 <a:cs typeface="Arial" pitchFamily="34" charset="-120"/>
               </a:rPr>
-              <a:t>FDA Establishment Registration</a:t>
+              <a:t>Enregistrement FDA</a:t>
             </a:r>
             <a:endParaRPr lang="en-US" sz="1100" dirty="0"/>
           </a:p>
@@ -19350,7 +19142,7 @@
                 <a:ea typeface="Arial" pitchFamily="34" charset="-122"/>
                 <a:cs typeface="Arial" pitchFamily="34" charset="-120"/>
               </a:rPr>
-              <a:t>Planned</a:t>
+              <a:t>Prévu</a:t>
             </a:r>
             <a:endParaRPr lang="en-US" sz="1000" dirty="0"/>
           </a:p>
@@ -19409,7 +19201,7 @@
                 <a:ea typeface="Arial" pitchFamily="34" charset="-122"/>
                 <a:cs typeface="Arial" pitchFamily="34" charset="-120"/>
               </a:rPr>
-              <a:t>AAFCO-aligned Labeling</a:t>
+              <a:t>Étiquetage conforme AAFCO</a:t>
             </a:r>
             <a:endParaRPr lang="en-US" sz="1100" dirty="0"/>
           </a:p>
@@ -19448,7 +19240,7 @@
                 <a:ea typeface="Arial" pitchFamily="34" charset="-122"/>
                 <a:cs typeface="Arial" pitchFamily="34" charset="-120"/>
               </a:rPr>
-              <a:t>Support Built In</a:t>
+              <a:t>Intégré nativement</a:t>
             </a:r>
             <a:endParaRPr lang="en-US" sz="1000" dirty="0"/>
           </a:p>
@@ -19507,7 +19299,7 @@
                 <a:ea typeface="Arial" pitchFamily="34" charset="-122"/>
                 <a:cs typeface="Arial" pitchFamily="34" charset="-120"/>
               </a:rPr>
-              <a:t>Full Batch Traceability</a:t>
+              <a:t>Traçabilité complète des lots</a:t>
             </a:r>
             <a:endParaRPr lang="en-US" sz="1100" dirty="0"/>
           </a:p>
@@ -19546,7 +19338,7 @@
                 <a:ea typeface="Arial" pitchFamily="34" charset="-122"/>
                 <a:cs typeface="Arial" pitchFamily="34" charset="-120"/>
               </a:rPr>
-              <a:t>Built into FAMSUN Line</a:t>
+              <a:t>Intégrée ligne FAMSUN</a:t>
             </a:r>
             <a:endParaRPr lang="en-US" sz="1000" dirty="0"/>
           </a:p>
@@ -19607,7 +19399,7 @@
                 <a:ea typeface="Calibri" pitchFamily="34" charset="-122"/>
                 <a:cs typeface="Calibri" pitchFamily="34" charset="-120"/>
               </a:rPr>
-              <a:t>Fire Safety &amp; Building</a:t>
+              <a:t>Sécurité Incendie &amp; Bâtiment</a:t>
             </a:r>
             <a:endParaRPr lang="en-US" sz="1800" dirty="0"/>
           </a:p>
@@ -19666,7 +19458,7 @@
                 <a:ea typeface="Arial" pitchFamily="34" charset="-122"/>
                 <a:cs typeface="Arial" pitchFamily="34" charset="-120"/>
               </a:rPr>
-              <a:t>Full NSI ERT fire safety dossier filed</a:t>
+              <a:t>Dossier complet sécurité incendie NSI ERT déposé</a:t>
             </a:r>
             <a:endParaRPr lang="en-US" sz="1100" dirty="0"/>
           </a:p>
@@ -19725,7 +19517,7 @@
                 <a:ea typeface="Arial" pitchFamily="34" charset="-122"/>
                 <a:cs typeface="Arial" pitchFamily="34" charset="-120"/>
               </a:rPr>
-              <a:t>PCI plans approved (ground &amp; 1st floor)</a:t>
+              <a:t>Plans PCI approuvés (RDC &amp; 1er étage)</a:t>
             </a:r>
             <a:endParaRPr lang="en-US" sz="1100" dirty="0"/>
           </a:p>
@@ -19784,7 +19576,7 @@
                 <a:ea typeface="Arial" pitchFamily="34" charset="-122"/>
                 <a:cs typeface="Arial" pitchFamily="34" charset="-120"/>
               </a:rPr>
-              <a:t>Fire pressurization system designed</a:t>
+              <a:t>Système de pressurisation incendie conçu</a:t>
             </a:r>
             <a:endParaRPr lang="en-US" sz="1100" dirty="0"/>
           </a:p>
@@ -19843,7 +19635,7 @@
                 <a:ea typeface="Arial" pitchFamily="34" charset="-122"/>
                 <a:cs typeface="Arial" pitchFamily="34" charset="-120"/>
               </a:rPr>
-              <a:t>Building modification authorization obtained</a:t>
+              <a:t>Autorisation de modification du bâtiment obtenue</a:t>
             </a:r>
             <a:endParaRPr lang="en-US" sz="1100" dirty="0"/>
           </a:p>
@@ -19902,7 +19694,7 @@
                 <a:ea typeface="Arial" pitchFamily="34" charset="-122"/>
                 <a:cs typeface="Arial" pitchFamily="34" charset="-120"/>
               </a:rPr>
-              <a:t>Soufiane Incendie as certified provider</a:t>
+              <a:t>Soufiane Incendie comme prestataire certifié</a:t>
             </a:r>
             <a:endParaRPr lang="en-US" sz="1100" dirty="0"/>
           </a:p>
@@ -19970,7 +19762,7 @@
                 <a:ea typeface="Calibri" pitchFamily="34" charset="-122"/>
                 <a:cs typeface="Calibri" pitchFamily="34" charset="-120"/>
               </a:rPr>
-              <a:t>FAMSUN Performance Guarantees</a:t>
+              <a:t>Garanties de Performance FAMSUN</a:t>
             </a:r>
             <a:endParaRPr lang="en-US" sz="1600" dirty="0"/>
           </a:p>
@@ -20009,7 +19801,7 @@
                 <a:ea typeface="Arial" pitchFamily="34" charset="-122"/>
                 <a:cs typeface="Arial" pitchFamily="34" charset="-120"/>
               </a:rPr>
-              <a:t>Penalty Clause:</a:t>
+              <a:t>Clause de pénalité :</a:t>
             </a:r>
             <a:endParaRPr lang="en-US" sz="1000" dirty="0"/>
           </a:p>
@@ -20048,7 +19840,7 @@
                 <a:ea typeface="Arial" pitchFamily="34" charset="-122"/>
                 <a:cs typeface="Arial" pitchFamily="34" charset="-120"/>
               </a:rPr>
-              <a:t>2% of contract price per 2% deviation below capacity</a:t>
+              <a:t>2% du prix contrat par 2% d'écart sous la capacité</a:t>
             </a:r>
             <a:endParaRPr lang="en-US" sz="1000" dirty="0"/>
           </a:p>
@@ -20087,7 +19879,7 @@
                 <a:ea typeface="Arial" pitchFamily="34" charset="-122"/>
                 <a:cs typeface="Arial" pitchFamily="34" charset="-120"/>
               </a:rPr>
-              <a:t>Maximum Penalty:</a:t>
+              <a:t>Pénalité maximale :</a:t>
             </a:r>
             <a:endParaRPr lang="en-US" sz="1000" dirty="0"/>
           </a:p>
@@ -20126,7 +19918,7 @@
                 <a:ea typeface="Arial" pitchFamily="34" charset="-122"/>
                 <a:cs typeface="Arial" pitchFamily="34" charset="-120"/>
               </a:rPr>
-              <a:t>10% per product; 20% total of contract price</a:t>
+              <a:t>10% par produit ; 20% du prix total du contrat</a:t>
             </a:r>
             <a:endParaRPr lang="en-US" sz="1000" dirty="0"/>
           </a:p>
@@ -20165,7 +19957,7 @@
                 <a:ea typeface="Arial" pitchFamily="34" charset="-122"/>
                 <a:cs typeface="Arial" pitchFamily="34" charset="-120"/>
               </a:rPr>
-              <a:t>Dog Food Milling:</a:t>
+              <a:t>Broyage aliment chien :</a:t>
             </a:r>
             <a:endParaRPr lang="en-US" sz="1000" dirty="0"/>
           </a:p>
@@ -20204,7 +19996,7 @@
                 <a:ea typeface="Arial" pitchFamily="34" charset="-122"/>
                 <a:cs typeface="Arial" pitchFamily="34" charset="-120"/>
               </a:rPr>
-              <a:t>Hammer mill 1.2mm sieve, D90 &lt; 800 μm</a:t>
+              <a:t>Broyeur à marteaux tamis 1,2 mm, D90 &lt; 800 μm</a:t>
             </a:r>
             <a:endParaRPr lang="en-US" sz="1000" dirty="0"/>
           </a:p>
@@ -20243,7 +20035,7 @@
                 <a:ea typeface="Arial" pitchFamily="34" charset="-122"/>
                 <a:cs typeface="Arial" pitchFamily="34" charset="-120"/>
               </a:rPr>
-              <a:t>Cat Food Milling:</a:t>
+              <a:t>Broyage aliment chat :</a:t>
             </a:r>
             <a:endParaRPr lang="en-US" sz="1000" dirty="0"/>
           </a:p>
@@ -20282,7 +20074,7 @@
                 <a:ea typeface="Arial" pitchFamily="34" charset="-122"/>
                 <a:cs typeface="Arial" pitchFamily="34" charset="-120"/>
               </a:rPr>
-              <a:t>Hammer mill 1.0mm sieve, D90 &lt; 500 μm</a:t>
+              <a:t>Broyeur à marteaux tamis 1,0 mm, D90 &lt; 500 μm</a:t>
             </a:r>
             <a:endParaRPr lang="en-US" sz="1000" dirty="0"/>
           </a:p>
@@ -20321,7 +20113,7 @@
                 <a:ea typeface="Arial" pitchFamily="34" charset="-122"/>
                 <a:cs typeface="Arial" pitchFamily="34" charset="-120"/>
               </a:rPr>
-              <a:t>PetFactory Maroc  |  Investor Update  |  August 2026</a:t>
+              <a:t>PetFactory Maroc  |  Mise à jour Investisseurs  |  Août 2026</a:t>
             </a:r>
             <a:endParaRPr lang="en-US" sz="800" dirty="0"/>
           </a:p>

</xml_diff>